<commit_message>
Added turret angle limits
</commit_message>
<xml_diff>
--- a/Euler/Euler.pptx
+++ b/Euler/Euler.pptx
@@ -7,6 +7,8 @@
   <p:sldIdLst>
     <p:sldId id="256" r:id="rId2"/>
     <p:sldId id="257" r:id="rId3"/>
+    <p:sldId id="258" r:id="rId4"/>
+    <p:sldId id="259" r:id="rId5"/>
   </p:sldIdLst>
   <p:sldSz cx="12192000" cy="6858000"/>
   <p:notesSz cx="6858000" cy="9144000"/>
@@ -105,6 +107,11 @@
       </a:defRPr>
     </a:lvl9pPr>
   </p:defaultTextStyle>
+  <p:extLst>
+    <p:ext uri="{EFAFB233-063F-42B5-8137-9DF3F51BA10A}">
+      <p15:sldGuideLst xmlns:p15="http://schemas.microsoft.com/office/powerpoint/2012/main"/>
+    </p:ext>
+  </p:extLst>
 </p:presentation>
 </file>
 
@@ -255,7 +262,7 @@
           <a:p>
             <a:fld id="{AA707B2D-9D38-4DD2-AA55-35A51E62F204}" type="datetimeFigureOut">
               <a:rPr lang="en-US" smtClean="0"/>
-              <a:t>5/14/2026</a:t>
+              <a:t>5/20/2026</a:t>
             </a:fld>
             <a:endParaRPr lang="en-US"/>
           </a:p>
@@ -453,7 +460,7 @@
           <a:p>
             <a:fld id="{AA707B2D-9D38-4DD2-AA55-35A51E62F204}" type="datetimeFigureOut">
               <a:rPr lang="en-US" smtClean="0"/>
-              <a:t>5/14/2026</a:t>
+              <a:t>5/20/2026</a:t>
             </a:fld>
             <a:endParaRPr lang="en-US"/>
           </a:p>
@@ -661,7 +668,7 @@
           <a:p>
             <a:fld id="{AA707B2D-9D38-4DD2-AA55-35A51E62F204}" type="datetimeFigureOut">
               <a:rPr lang="en-US" smtClean="0"/>
-              <a:t>5/14/2026</a:t>
+              <a:t>5/20/2026</a:t>
             </a:fld>
             <a:endParaRPr lang="en-US"/>
           </a:p>
@@ -859,7 +866,7 @@
           <a:p>
             <a:fld id="{AA707B2D-9D38-4DD2-AA55-35A51E62F204}" type="datetimeFigureOut">
               <a:rPr lang="en-US" smtClean="0"/>
-              <a:t>5/14/2026</a:t>
+              <a:t>5/20/2026</a:t>
             </a:fld>
             <a:endParaRPr lang="en-US"/>
           </a:p>
@@ -1134,7 +1141,7 @@
           <a:p>
             <a:fld id="{AA707B2D-9D38-4DD2-AA55-35A51E62F204}" type="datetimeFigureOut">
               <a:rPr lang="en-US" smtClean="0"/>
-              <a:t>5/14/2026</a:t>
+              <a:t>5/20/2026</a:t>
             </a:fld>
             <a:endParaRPr lang="en-US"/>
           </a:p>
@@ -1399,7 +1406,7 @@
           <a:p>
             <a:fld id="{AA707B2D-9D38-4DD2-AA55-35A51E62F204}" type="datetimeFigureOut">
               <a:rPr lang="en-US" smtClean="0"/>
-              <a:t>5/14/2026</a:t>
+              <a:t>5/20/2026</a:t>
             </a:fld>
             <a:endParaRPr lang="en-US"/>
           </a:p>
@@ -1811,7 +1818,7 @@
           <a:p>
             <a:fld id="{AA707B2D-9D38-4DD2-AA55-35A51E62F204}" type="datetimeFigureOut">
               <a:rPr lang="en-US" smtClean="0"/>
-              <a:t>5/14/2026</a:t>
+              <a:t>5/20/2026</a:t>
             </a:fld>
             <a:endParaRPr lang="en-US"/>
           </a:p>
@@ -1952,7 +1959,7 @@
           <a:p>
             <a:fld id="{AA707B2D-9D38-4DD2-AA55-35A51E62F204}" type="datetimeFigureOut">
               <a:rPr lang="en-US" smtClean="0"/>
-              <a:t>5/14/2026</a:t>
+              <a:t>5/20/2026</a:t>
             </a:fld>
             <a:endParaRPr lang="en-US"/>
           </a:p>
@@ -2065,7 +2072,7 @@
           <a:p>
             <a:fld id="{AA707B2D-9D38-4DD2-AA55-35A51E62F204}" type="datetimeFigureOut">
               <a:rPr lang="en-US" smtClean="0"/>
-              <a:t>5/14/2026</a:t>
+              <a:t>5/20/2026</a:t>
             </a:fld>
             <a:endParaRPr lang="en-US"/>
           </a:p>
@@ -2376,7 +2383,7 @@
           <a:p>
             <a:fld id="{AA707B2D-9D38-4DD2-AA55-35A51E62F204}" type="datetimeFigureOut">
               <a:rPr lang="en-US" smtClean="0"/>
-              <a:t>5/14/2026</a:t>
+              <a:t>5/20/2026</a:t>
             </a:fld>
             <a:endParaRPr lang="en-US"/>
           </a:p>
@@ -2664,7 +2671,7 @@
           <a:p>
             <a:fld id="{AA707B2D-9D38-4DD2-AA55-35A51E62F204}" type="datetimeFigureOut">
               <a:rPr lang="en-US" smtClean="0"/>
-              <a:t>5/14/2026</a:t>
+              <a:t>5/20/2026</a:t>
             </a:fld>
             <a:endParaRPr lang="en-US"/>
           </a:p>
@@ -2905,7 +2912,7 @@
           <a:p>
             <a:fld id="{AA707B2D-9D38-4DD2-AA55-35A51E62F204}" type="datetimeFigureOut">
               <a:rPr lang="en-US" smtClean="0"/>
-              <a:t>5/14/2026</a:t>
+              <a:t>5/20/2026</a:t>
             </a:fld>
             <a:endParaRPr lang="en-US"/>
           </a:p>
@@ -3820,8 +3827,8 @@
           </a:fontRef>
         </p:style>
       </p:cxnSp>
-      <mc:AlternateContent xmlns:mc="http://schemas.openxmlformats.org/markup-compatibility/2006">
-        <mc:Choice xmlns:a14="http://schemas.microsoft.com/office/drawing/2010/main" Requires="a14">
+      <mc:AlternateContent xmlns:mc="http://schemas.openxmlformats.org/markup-compatibility/2006" xmlns:a14="http://schemas.microsoft.com/office/drawing/2010/main">
+        <mc:Choice Requires="a14">
           <p:sp>
             <p:nvSpPr>
               <p:cNvPr id="17" name="TextBox 16">
@@ -3874,7 +3881,7 @@
             </p:txBody>
           </p:sp>
         </mc:Choice>
-        <mc:Fallback>
+        <mc:Fallback xmlns="">
           <p:sp>
             <p:nvSpPr>
               <p:cNvPr id="17" name="TextBox 16">
@@ -3919,8 +3926,8 @@
           </p:sp>
         </mc:Fallback>
       </mc:AlternateContent>
-      <mc:AlternateContent xmlns:mc="http://schemas.openxmlformats.org/markup-compatibility/2006">
-        <mc:Choice xmlns:a14="http://schemas.microsoft.com/office/drawing/2010/main" Requires="a14">
+      <mc:AlternateContent xmlns:mc="http://schemas.openxmlformats.org/markup-compatibility/2006" xmlns:a14="http://schemas.microsoft.com/office/drawing/2010/main">
+        <mc:Choice Requires="a14">
           <p:sp>
             <p:nvSpPr>
               <p:cNvPr id="18" name="TextBox 17">
@@ -3998,7 +4005,7 @@
             </p:txBody>
           </p:sp>
         </mc:Choice>
-        <mc:Fallback>
+        <mc:Fallback xmlns="">
           <p:sp>
             <p:nvSpPr>
               <p:cNvPr id="18" name="TextBox 17">
@@ -4043,8 +4050,8 @@
           </p:sp>
         </mc:Fallback>
       </mc:AlternateContent>
-      <mc:AlternateContent xmlns:mc="http://schemas.openxmlformats.org/markup-compatibility/2006">
-        <mc:Choice xmlns:a14="http://schemas.microsoft.com/office/drawing/2010/main" Requires="a14">
+      <mc:AlternateContent xmlns:mc="http://schemas.openxmlformats.org/markup-compatibility/2006" xmlns:a14="http://schemas.microsoft.com/office/drawing/2010/main">
+        <mc:Choice Requires="a14">
           <p:sp>
             <p:nvSpPr>
               <p:cNvPr id="19" name="TextBox 18">
@@ -4122,7 +4129,7 @@
             </p:txBody>
           </p:sp>
         </mc:Choice>
-        <mc:Fallback>
+        <mc:Fallback xmlns="">
           <p:sp>
             <p:nvSpPr>
               <p:cNvPr id="19" name="TextBox 18">
@@ -4167,8 +4174,8 @@
           </p:sp>
         </mc:Fallback>
       </mc:AlternateContent>
-      <mc:AlternateContent xmlns:mc="http://schemas.openxmlformats.org/markup-compatibility/2006">
-        <mc:Choice xmlns:a14="http://schemas.microsoft.com/office/drawing/2010/main" Requires="a14">
+      <mc:AlternateContent xmlns:mc="http://schemas.openxmlformats.org/markup-compatibility/2006" xmlns:a14="http://schemas.microsoft.com/office/drawing/2010/main">
+        <mc:Choice Requires="a14">
           <p:sp>
             <p:nvSpPr>
               <p:cNvPr id="20" name="TextBox 19">
@@ -4250,7 +4257,7 @@
             </p:txBody>
           </p:sp>
         </mc:Choice>
-        <mc:Fallback>
+        <mc:Fallback xmlns="">
           <p:sp>
             <p:nvSpPr>
               <p:cNvPr id="20" name="TextBox 19">
@@ -4295,8 +4302,8 @@
           </p:sp>
         </mc:Fallback>
       </mc:AlternateContent>
-      <mc:AlternateContent xmlns:mc="http://schemas.openxmlformats.org/markup-compatibility/2006">
-        <mc:Choice xmlns:a14="http://schemas.microsoft.com/office/drawing/2010/main" Requires="a14">
+      <mc:AlternateContent xmlns:mc="http://schemas.openxmlformats.org/markup-compatibility/2006" xmlns:a14="http://schemas.microsoft.com/office/drawing/2010/main">
+        <mc:Choice Requires="a14">
           <p:sp>
             <p:nvSpPr>
               <p:cNvPr id="21" name="TextBox 20">
@@ -4350,7 +4357,7 @@
             </p:txBody>
           </p:sp>
         </mc:Choice>
-        <mc:Fallback>
+        <mc:Fallback xmlns="">
           <p:sp>
             <p:nvSpPr>
               <p:cNvPr id="21" name="TextBox 20">
@@ -4395,8 +4402,8 @@
           </p:sp>
         </mc:Fallback>
       </mc:AlternateContent>
-      <mc:AlternateContent xmlns:mc="http://schemas.openxmlformats.org/markup-compatibility/2006">
-        <mc:Choice xmlns:a14="http://schemas.microsoft.com/office/drawing/2010/main" Requires="a14">
+      <mc:AlternateContent xmlns:mc="http://schemas.openxmlformats.org/markup-compatibility/2006" xmlns:a14="http://schemas.microsoft.com/office/drawing/2010/main">
+        <mc:Choice Requires="a14">
           <p:sp>
             <p:nvSpPr>
               <p:cNvPr id="22" name="TextBox 21">
@@ -4458,7 +4465,7 @@
             </p:txBody>
           </p:sp>
         </mc:Choice>
-        <mc:Fallback>
+        <mc:Fallback xmlns="">
           <p:sp>
             <p:nvSpPr>
               <p:cNvPr id="22" name="TextBox 21">
@@ -4503,8 +4510,8 @@
           </p:sp>
         </mc:Fallback>
       </mc:AlternateContent>
-      <mc:AlternateContent xmlns:mc="http://schemas.openxmlformats.org/markup-compatibility/2006">
-        <mc:Choice xmlns:a14="http://schemas.microsoft.com/office/drawing/2010/main" Requires="a14">
+      <mc:AlternateContent xmlns:mc="http://schemas.openxmlformats.org/markup-compatibility/2006" xmlns:a14="http://schemas.microsoft.com/office/drawing/2010/main">
+        <mc:Choice Requires="a14">
           <p:sp>
             <p:nvSpPr>
               <p:cNvPr id="23" name="TextBox 22">
@@ -4561,7 +4568,7 @@
             </p:txBody>
           </p:sp>
         </mc:Choice>
-        <mc:Fallback>
+        <mc:Fallback xmlns="">
           <p:sp>
             <p:nvSpPr>
               <p:cNvPr id="23" name="TextBox 22">
@@ -4606,8 +4613,8 @@
           </p:sp>
         </mc:Fallback>
       </mc:AlternateContent>
-      <mc:AlternateContent xmlns:mc="http://schemas.openxmlformats.org/markup-compatibility/2006">
-        <mc:Choice xmlns:a14="http://schemas.microsoft.com/office/drawing/2010/main" Requires="a14">
+      <mc:AlternateContent xmlns:mc="http://schemas.openxmlformats.org/markup-compatibility/2006" xmlns:a14="http://schemas.microsoft.com/office/drawing/2010/main">
+        <mc:Choice Requires="a14">
           <p:sp>
             <p:nvSpPr>
               <p:cNvPr id="24" name="TextBox 23">
@@ -4685,7 +4692,7 @@
             </p:txBody>
           </p:sp>
         </mc:Choice>
-        <mc:Fallback>
+        <mc:Fallback xmlns="">
           <p:sp>
             <p:nvSpPr>
               <p:cNvPr id="24" name="TextBox 23">
@@ -4730,8 +4737,8 @@
           </p:sp>
         </mc:Fallback>
       </mc:AlternateContent>
-      <mc:AlternateContent xmlns:mc="http://schemas.openxmlformats.org/markup-compatibility/2006">
-        <mc:Choice xmlns:a14="http://schemas.microsoft.com/office/drawing/2010/main" Requires="a14">
+      <mc:AlternateContent xmlns:mc="http://schemas.openxmlformats.org/markup-compatibility/2006" xmlns:a14="http://schemas.microsoft.com/office/drawing/2010/main">
+        <mc:Choice Requires="a14">
           <p:sp>
             <p:nvSpPr>
               <p:cNvPr id="25" name="TextBox 24">
@@ -4760,6 +4767,7 @@
               </a:bodyPr>
               <a:lstStyle/>
               <a:p>
+                <a:pPr/>
                 <a14:m>
                   <m:oMathPara xmlns:m="http://schemas.openxmlformats.org/officeDocument/2006/math">
                     <m:oMathParaPr>
@@ -4780,7 +4788,7 @@
             </p:txBody>
           </p:sp>
         </mc:Choice>
-        <mc:Fallback>
+        <mc:Fallback xmlns="">
           <p:sp>
             <p:nvSpPr>
               <p:cNvPr id="25" name="TextBox 24">
@@ -4825,8 +4833,8 @@
           </p:sp>
         </mc:Fallback>
       </mc:AlternateContent>
-      <mc:AlternateContent xmlns:mc="http://schemas.openxmlformats.org/markup-compatibility/2006">
-        <mc:Choice xmlns:a14="http://schemas.microsoft.com/office/drawing/2010/main" Requires="a14">
+      <mc:AlternateContent xmlns:mc="http://schemas.openxmlformats.org/markup-compatibility/2006" xmlns:a14="http://schemas.microsoft.com/office/drawing/2010/main">
+        <mc:Choice Requires="a14">
           <p:sp>
             <p:nvSpPr>
               <p:cNvPr id="26" name="TextBox 25">
@@ -4855,6 +4863,7 @@
               </a:bodyPr>
               <a:lstStyle/>
               <a:p>
+                <a:pPr/>
                 <a14:m>
                   <m:oMathPara xmlns:m="http://schemas.openxmlformats.org/officeDocument/2006/math">
                     <m:oMathParaPr>
@@ -4875,7 +4884,7 @@
             </p:txBody>
           </p:sp>
         </mc:Choice>
-        <mc:Fallback>
+        <mc:Fallback xmlns="">
           <p:sp>
             <p:nvSpPr>
               <p:cNvPr id="26" name="TextBox 25">
@@ -5357,8 +5366,8 @@
           </a:fontRef>
         </p:style>
       </p:cxnSp>
-      <mc:AlternateContent xmlns:mc="http://schemas.openxmlformats.org/markup-compatibility/2006">
-        <mc:Choice xmlns:a14="http://schemas.microsoft.com/office/drawing/2010/main" Requires="a14">
+      <mc:AlternateContent xmlns:mc="http://schemas.openxmlformats.org/markup-compatibility/2006" xmlns:a14="http://schemas.microsoft.com/office/drawing/2010/main">
+        <mc:Choice Requires="a14">
           <p:sp>
             <p:nvSpPr>
               <p:cNvPr id="17" name="TextBox 16">
@@ -5415,7 +5424,7 @@
             </p:txBody>
           </p:sp>
         </mc:Choice>
-        <mc:Fallback>
+        <mc:Fallback xmlns="">
           <p:sp>
             <p:nvSpPr>
               <p:cNvPr id="17" name="TextBox 16">
@@ -5460,8 +5469,8 @@
           </p:sp>
         </mc:Fallback>
       </mc:AlternateContent>
-      <mc:AlternateContent xmlns:mc="http://schemas.openxmlformats.org/markup-compatibility/2006">
-        <mc:Choice xmlns:a14="http://schemas.microsoft.com/office/drawing/2010/main" Requires="a14">
+      <mc:AlternateContent xmlns:mc="http://schemas.openxmlformats.org/markup-compatibility/2006" xmlns:a14="http://schemas.microsoft.com/office/drawing/2010/main">
+        <mc:Choice Requires="a14">
           <p:sp>
             <p:nvSpPr>
               <p:cNvPr id="18" name="TextBox 17">
@@ -5543,7 +5552,7 @@
             </p:txBody>
           </p:sp>
         </mc:Choice>
-        <mc:Fallback>
+        <mc:Fallback xmlns="">
           <p:sp>
             <p:nvSpPr>
               <p:cNvPr id="18" name="TextBox 17">
@@ -5588,8 +5597,8 @@
           </p:sp>
         </mc:Fallback>
       </mc:AlternateContent>
-      <mc:AlternateContent xmlns:mc="http://schemas.openxmlformats.org/markup-compatibility/2006">
-        <mc:Choice xmlns:a14="http://schemas.microsoft.com/office/drawing/2010/main" Requires="a14">
+      <mc:AlternateContent xmlns:mc="http://schemas.openxmlformats.org/markup-compatibility/2006" xmlns:a14="http://schemas.microsoft.com/office/drawing/2010/main">
+        <mc:Choice Requires="a14">
           <p:sp>
             <p:nvSpPr>
               <p:cNvPr id="19" name="TextBox 18">
@@ -5671,7 +5680,7 @@
             </p:txBody>
           </p:sp>
         </mc:Choice>
-        <mc:Fallback>
+        <mc:Fallback xmlns="">
           <p:sp>
             <p:nvSpPr>
               <p:cNvPr id="19" name="TextBox 18">
@@ -5716,8 +5725,8 @@
           </p:sp>
         </mc:Fallback>
       </mc:AlternateContent>
-      <mc:AlternateContent xmlns:mc="http://schemas.openxmlformats.org/markup-compatibility/2006">
-        <mc:Choice xmlns:a14="http://schemas.microsoft.com/office/drawing/2010/main" Requires="a14">
+      <mc:AlternateContent xmlns:mc="http://schemas.openxmlformats.org/markup-compatibility/2006" xmlns:a14="http://schemas.microsoft.com/office/drawing/2010/main">
+        <mc:Choice Requires="a14">
           <p:sp>
             <p:nvSpPr>
               <p:cNvPr id="20" name="TextBox 19">
@@ -5799,7 +5808,7 @@
             </p:txBody>
           </p:sp>
         </mc:Choice>
-        <mc:Fallback>
+        <mc:Fallback xmlns="">
           <p:sp>
             <p:nvSpPr>
               <p:cNvPr id="20" name="TextBox 19">
@@ -5844,8 +5853,8 @@
           </p:sp>
         </mc:Fallback>
       </mc:AlternateContent>
-      <mc:AlternateContent xmlns:mc="http://schemas.openxmlformats.org/markup-compatibility/2006">
-        <mc:Choice xmlns:a14="http://schemas.microsoft.com/office/drawing/2010/main" Requires="a14">
+      <mc:AlternateContent xmlns:mc="http://schemas.openxmlformats.org/markup-compatibility/2006" xmlns:a14="http://schemas.microsoft.com/office/drawing/2010/main">
+        <mc:Choice Requires="a14">
           <p:sp>
             <p:nvSpPr>
               <p:cNvPr id="21" name="TextBox 20">
@@ -5903,7 +5912,7 @@
             </p:txBody>
           </p:sp>
         </mc:Choice>
-        <mc:Fallback>
+        <mc:Fallback xmlns="">
           <p:sp>
             <p:nvSpPr>
               <p:cNvPr id="21" name="TextBox 20">
@@ -5948,8 +5957,8 @@
           </p:sp>
         </mc:Fallback>
       </mc:AlternateContent>
-      <mc:AlternateContent xmlns:mc="http://schemas.openxmlformats.org/markup-compatibility/2006">
-        <mc:Choice xmlns:a14="http://schemas.microsoft.com/office/drawing/2010/main" Requires="a14">
+      <mc:AlternateContent xmlns:mc="http://schemas.openxmlformats.org/markup-compatibility/2006" xmlns:a14="http://schemas.microsoft.com/office/drawing/2010/main">
+        <mc:Choice Requires="a14">
           <p:sp>
             <p:nvSpPr>
               <p:cNvPr id="22" name="TextBox 21">
@@ -6011,7 +6020,7 @@
             </p:txBody>
           </p:sp>
         </mc:Choice>
-        <mc:Fallback>
+        <mc:Fallback xmlns="">
           <p:sp>
             <p:nvSpPr>
               <p:cNvPr id="22" name="TextBox 21">
@@ -6056,8 +6065,8 @@
           </p:sp>
         </mc:Fallback>
       </mc:AlternateContent>
-      <mc:AlternateContent xmlns:mc="http://schemas.openxmlformats.org/markup-compatibility/2006">
-        <mc:Choice xmlns:a14="http://schemas.microsoft.com/office/drawing/2010/main" Requires="a14">
+      <mc:AlternateContent xmlns:mc="http://schemas.openxmlformats.org/markup-compatibility/2006" xmlns:a14="http://schemas.microsoft.com/office/drawing/2010/main">
+        <mc:Choice Requires="a14">
           <p:sp>
             <p:nvSpPr>
               <p:cNvPr id="23" name="TextBox 22">
@@ -6114,7 +6123,7 @@
             </p:txBody>
           </p:sp>
         </mc:Choice>
-        <mc:Fallback>
+        <mc:Fallback xmlns="">
           <p:sp>
             <p:nvSpPr>
               <p:cNvPr id="23" name="TextBox 22">
@@ -6159,8 +6168,8 @@
           </p:sp>
         </mc:Fallback>
       </mc:AlternateContent>
-      <mc:AlternateContent xmlns:mc="http://schemas.openxmlformats.org/markup-compatibility/2006">
-        <mc:Choice xmlns:a14="http://schemas.microsoft.com/office/drawing/2010/main" Requires="a14">
+      <mc:AlternateContent xmlns:mc="http://schemas.openxmlformats.org/markup-compatibility/2006" xmlns:a14="http://schemas.microsoft.com/office/drawing/2010/main">
+        <mc:Choice Requires="a14">
           <p:sp>
             <p:nvSpPr>
               <p:cNvPr id="24" name="TextBox 23">
@@ -6242,7 +6251,7 @@
             </p:txBody>
           </p:sp>
         </mc:Choice>
-        <mc:Fallback>
+        <mc:Fallback xmlns="">
           <p:sp>
             <p:nvSpPr>
               <p:cNvPr id="24" name="TextBox 23">
@@ -6420,8 +6429,8 @@
           </a:fontRef>
         </p:style>
       </p:cxnSp>
-      <mc:AlternateContent xmlns:mc="http://schemas.openxmlformats.org/markup-compatibility/2006">
-        <mc:Choice xmlns:a14="http://schemas.microsoft.com/office/drawing/2010/main" Requires="a14">
+      <mc:AlternateContent xmlns:mc="http://schemas.openxmlformats.org/markup-compatibility/2006" xmlns:a14="http://schemas.microsoft.com/office/drawing/2010/main">
+        <mc:Choice Requires="a14">
           <p:sp>
             <p:nvSpPr>
               <p:cNvPr id="7" name="TextBox 6">
@@ -6450,6 +6459,7 @@
               </a:bodyPr>
               <a:lstStyle/>
               <a:p>
+                <a:pPr/>
                 <a14:m>
                   <m:oMathPara xmlns:m="http://schemas.openxmlformats.org/officeDocument/2006/math">
                     <m:oMathParaPr>
@@ -6470,7 +6480,7 @@
             </p:txBody>
           </p:sp>
         </mc:Choice>
-        <mc:Fallback>
+        <mc:Fallback xmlns="">
           <p:sp>
             <p:nvSpPr>
               <p:cNvPr id="7" name="TextBox 6">
@@ -6515,8 +6525,8 @@
           </p:sp>
         </mc:Fallback>
       </mc:AlternateContent>
-      <mc:AlternateContent xmlns:mc="http://schemas.openxmlformats.org/markup-compatibility/2006">
-        <mc:Choice xmlns:a14="http://schemas.microsoft.com/office/drawing/2010/main" Requires="a14">
+      <mc:AlternateContent xmlns:mc="http://schemas.openxmlformats.org/markup-compatibility/2006" xmlns:a14="http://schemas.microsoft.com/office/drawing/2010/main">
+        <mc:Choice Requires="a14">
           <p:sp>
             <p:nvSpPr>
               <p:cNvPr id="25" name="TextBox 24">
@@ -6545,6 +6555,7 @@
               </a:bodyPr>
               <a:lstStyle/>
               <a:p>
+                <a:pPr/>
                 <a14:m>
                   <m:oMathPara xmlns:m="http://schemas.openxmlformats.org/officeDocument/2006/math">
                     <m:oMathParaPr>
@@ -6565,7 +6576,7 @@
             </p:txBody>
           </p:sp>
         </mc:Choice>
-        <mc:Fallback>
+        <mc:Fallback xmlns="">
           <p:sp>
             <p:nvSpPr>
               <p:cNvPr id="25" name="TextBox 24">
@@ -6656,6 +6667,4184 @@
   <p:clrMapOvr>
     <a:masterClrMapping/>
   </p:clrMapOvr>
+</p:sld>
+</file>
+
+<file path=ppt/slides/slide3.xml><?xml version="1.0" encoding="utf-8"?>
+<p:sld xmlns:a="http://schemas.openxmlformats.org/drawingml/2006/main" xmlns:r="http://schemas.openxmlformats.org/officeDocument/2006/relationships" xmlns:p="http://schemas.openxmlformats.org/presentationml/2006/main">
+  <p:cSld>
+    <p:spTree>
+      <p:nvGrpSpPr>
+        <p:cNvPr id="1" name=""/>
+        <p:cNvGrpSpPr/>
+        <p:nvPr/>
+      </p:nvGrpSpPr>
+      <p:grpSpPr>
+        <a:xfrm>
+          <a:off x="0" y="0"/>
+          <a:ext cx="0" cy="0"/>
+          <a:chOff x="0" y="0"/>
+          <a:chExt cx="0" cy="0"/>
+        </a:xfrm>
+      </p:grpSpPr>
+      <mc:AlternateContent xmlns:mc="http://schemas.openxmlformats.org/markup-compatibility/2006">
+        <mc:Choice xmlns:a14="http://schemas.microsoft.com/office/drawing/2010/main" Requires="a14">
+          <p:sp>
+            <p:nvSpPr>
+              <p:cNvPr id="3" name="Content Placeholder 2">
+                <a:extLst>
+                  <a:ext uri="{FF2B5EF4-FFF2-40B4-BE49-F238E27FC236}">
+                    <a16:creationId xmlns:a16="http://schemas.microsoft.com/office/drawing/2014/main" id="{A708DF32-6843-271E-385E-8FD16F2FEF16}"/>
+                  </a:ext>
+                </a:extLst>
+              </p:cNvPr>
+              <p:cNvSpPr>
+                <a:spLocks noGrp="1"/>
+              </p:cNvSpPr>
+              <p:nvPr>
+                <p:ph idx="1"/>
+              </p:nvPr>
+            </p:nvSpPr>
+            <p:spPr>
+              <a:xfrm>
+                <a:off x="441036" y="1262207"/>
+                <a:ext cx="6001882" cy="4351338"/>
+              </a:xfrm>
+            </p:spPr>
+            <p:txBody>
+              <a:bodyPr/>
+              <a:lstStyle/>
+              <a:p>
+                <a:pPr marL="0" indent="0">
+                  <a:buNone/>
+                </a:pPr>
+                <a14:m>
+                  <m:oMathPara xmlns:m="http://schemas.openxmlformats.org/officeDocument/2006/math">
+                    <m:oMathParaPr>
+                      <m:jc m:val="centerGroup"/>
+                    </m:oMathParaPr>
+                    <m:oMath xmlns:m="http://schemas.openxmlformats.org/officeDocument/2006/math">
+                      <m:acc>
+                        <m:accPr>
+                          <m:chr m:val="̇"/>
+                          <m:ctrlPr>
+                            <a:rPr lang="en-US" i="1" smtClean="0">
+                              <a:latin typeface="Cambria Math" panose="02040503050406030204" pitchFamily="18" charset="0"/>
+                            </a:rPr>
+                          </m:ctrlPr>
+                        </m:accPr>
+                        <m:e>
+                          <m:r>
+                            <a:rPr lang="en-US" i="1" smtClean="0">
+                              <a:latin typeface="Cambria Math" panose="02040503050406030204" pitchFamily="18" charset="0"/>
+                              <a:ea typeface="Cambria Math" panose="02040503050406030204" pitchFamily="18" charset="0"/>
+                            </a:rPr>
+                            <m:t>𝜃</m:t>
+                          </m:r>
+                        </m:e>
+                      </m:acc>
+                      <m:r>
+                        <a:rPr lang="en-US" b="0" i="1" smtClean="0">
+                          <a:latin typeface="Cambria Math" panose="02040503050406030204" pitchFamily="18" charset="0"/>
+                        </a:rPr>
+                        <m:t>=</m:t>
+                      </m:r>
+                      <m:r>
+                        <a:rPr lang="en-US" b="0" i="1" smtClean="0">
+                          <a:latin typeface="Cambria Math" panose="02040503050406030204" pitchFamily="18" charset="0"/>
+                        </a:rPr>
+                        <m:t>𝑞</m:t>
+                      </m:r>
+                      <m:func>
+                        <m:funcPr>
+                          <m:ctrlPr>
+                            <a:rPr lang="en-US" b="0" i="1" smtClean="0">
+                              <a:latin typeface="Cambria Math" panose="02040503050406030204" pitchFamily="18" charset="0"/>
+                            </a:rPr>
+                          </m:ctrlPr>
+                        </m:funcPr>
+                        <m:fName>
+                          <m:r>
+                            <m:rPr>
+                              <m:sty m:val="p"/>
+                            </m:rPr>
+                            <a:rPr lang="en-US" b="0" i="0" smtClean="0">
+                              <a:latin typeface="Cambria Math" panose="02040503050406030204" pitchFamily="18" charset="0"/>
+                            </a:rPr>
+                            <m:t>cos</m:t>
+                          </m:r>
+                        </m:fName>
+                        <m:e>
+                          <m:r>
+                            <a:rPr lang="en-US" b="0" i="1" smtClean="0">
+                              <a:latin typeface="Cambria Math" panose="02040503050406030204" pitchFamily="18" charset="0"/>
+                              <a:ea typeface="Cambria Math" panose="02040503050406030204" pitchFamily="18" charset="0"/>
+                            </a:rPr>
+                            <m:t>𝜙</m:t>
+                          </m:r>
+                        </m:e>
+                      </m:func>
+                      <m:r>
+                        <a:rPr lang="en-US" b="0" i="1" smtClean="0">
+                          <a:latin typeface="Cambria Math" panose="02040503050406030204" pitchFamily="18" charset="0"/>
+                        </a:rPr>
+                        <m:t>−</m:t>
+                      </m:r>
+                      <m:r>
+                        <a:rPr lang="en-US" b="0" i="1" smtClean="0">
+                          <a:latin typeface="Cambria Math" panose="02040503050406030204" pitchFamily="18" charset="0"/>
+                        </a:rPr>
+                        <m:t>𝑟</m:t>
+                      </m:r>
+                      <m:func>
+                        <m:funcPr>
+                          <m:ctrlPr>
+                            <a:rPr lang="en-US" b="0" i="1" smtClean="0">
+                              <a:latin typeface="Cambria Math" panose="02040503050406030204" pitchFamily="18" charset="0"/>
+                            </a:rPr>
+                          </m:ctrlPr>
+                        </m:funcPr>
+                        <m:fName>
+                          <m:r>
+                            <m:rPr>
+                              <m:sty m:val="p"/>
+                            </m:rPr>
+                            <a:rPr lang="en-US" b="0" i="0" smtClean="0">
+                              <a:latin typeface="Cambria Math" panose="02040503050406030204" pitchFamily="18" charset="0"/>
+                            </a:rPr>
+                            <m:t>sin</m:t>
+                          </m:r>
+                        </m:fName>
+                        <m:e>
+                          <m:r>
+                            <a:rPr lang="en-US" b="0" i="1" smtClean="0">
+                              <a:latin typeface="Cambria Math" panose="02040503050406030204" pitchFamily="18" charset="0"/>
+                              <a:ea typeface="Cambria Math" panose="02040503050406030204" pitchFamily="18" charset="0"/>
+                            </a:rPr>
+                            <m:t>𝜙</m:t>
+                          </m:r>
+                        </m:e>
+                      </m:func>
+                    </m:oMath>
+                  </m:oMathPara>
+                </a14:m>
+                <a:endParaRPr lang="en-US" b="0" dirty="0"/>
+              </a:p>
+              <a:p>
+                <a:pPr marL="0" indent="0">
+                  <a:buNone/>
+                </a:pPr>
+                <a:endParaRPr lang="en-US" sz="1200" b="0" dirty="0"/>
+              </a:p>
+              <a:p>
+                <a:pPr marL="0" indent="0">
+                  <a:buNone/>
+                </a:pPr>
+                <a14:m>
+                  <m:oMathPara xmlns:m="http://schemas.openxmlformats.org/officeDocument/2006/math">
+                    <m:oMathParaPr>
+                      <m:jc m:val="centerGroup"/>
+                    </m:oMathParaPr>
+                    <m:oMath xmlns:m="http://schemas.openxmlformats.org/officeDocument/2006/math">
+                      <m:acc>
+                        <m:accPr>
+                          <m:chr m:val="̇"/>
+                          <m:ctrlPr>
+                            <a:rPr lang="en-US" i="1" smtClean="0">
+                              <a:latin typeface="Cambria Math" panose="02040503050406030204" pitchFamily="18" charset="0"/>
+                            </a:rPr>
+                          </m:ctrlPr>
+                        </m:accPr>
+                        <m:e>
+                          <m:r>
+                            <a:rPr lang="en-US" i="1" smtClean="0">
+                              <a:latin typeface="Cambria Math" panose="02040503050406030204" pitchFamily="18" charset="0"/>
+                              <a:ea typeface="Cambria Math" panose="02040503050406030204" pitchFamily="18" charset="0"/>
+                            </a:rPr>
+                            <m:t>𝜓</m:t>
+                          </m:r>
+                        </m:e>
+                      </m:acc>
+                      <m:r>
+                        <a:rPr lang="en-US" b="0" i="1" smtClean="0">
+                          <a:latin typeface="Cambria Math" panose="02040503050406030204" pitchFamily="18" charset="0"/>
+                        </a:rPr>
+                        <m:t>=</m:t>
+                      </m:r>
+                      <m:r>
+                        <a:rPr lang="en-US" b="0" i="1" smtClean="0">
+                          <a:latin typeface="Cambria Math" panose="02040503050406030204" pitchFamily="18" charset="0"/>
+                        </a:rPr>
+                        <m:t>𝑞</m:t>
+                      </m:r>
+                      <m:f>
+                        <m:fPr>
+                          <m:ctrlPr>
+                            <a:rPr lang="en-US" b="0" i="1" smtClean="0">
+                              <a:latin typeface="Cambria Math" panose="02040503050406030204" pitchFamily="18" charset="0"/>
+                            </a:rPr>
+                          </m:ctrlPr>
+                        </m:fPr>
+                        <m:num>
+                          <m:func>
+                            <m:funcPr>
+                              <m:ctrlPr>
+                                <a:rPr lang="en-US" b="0" i="1" smtClean="0">
+                                  <a:latin typeface="Cambria Math" panose="02040503050406030204" pitchFamily="18" charset="0"/>
+                                </a:rPr>
+                              </m:ctrlPr>
+                            </m:funcPr>
+                            <m:fName>
+                              <m:r>
+                                <m:rPr>
+                                  <m:sty m:val="p"/>
+                                </m:rPr>
+                                <a:rPr lang="en-US" b="0" i="0" smtClean="0">
+                                  <a:latin typeface="Cambria Math" panose="02040503050406030204" pitchFamily="18" charset="0"/>
+                                </a:rPr>
+                                <m:t>sin</m:t>
+                              </m:r>
+                            </m:fName>
+                            <m:e>
+                              <m:r>
+                                <a:rPr lang="en-US" b="0" i="1" smtClean="0">
+                                  <a:latin typeface="Cambria Math" panose="02040503050406030204" pitchFamily="18" charset="0"/>
+                                  <a:ea typeface="Cambria Math" panose="02040503050406030204" pitchFamily="18" charset="0"/>
+                                </a:rPr>
+                                <m:t>𝜙</m:t>
+                              </m:r>
+                            </m:e>
+                          </m:func>
+                        </m:num>
+                        <m:den>
+                          <m:func>
+                            <m:funcPr>
+                              <m:ctrlPr>
+                                <a:rPr lang="en-US" b="0" i="1" smtClean="0">
+                                  <a:latin typeface="Cambria Math" panose="02040503050406030204" pitchFamily="18" charset="0"/>
+                                </a:rPr>
+                              </m:ctrlPr>
+                            </m:funcPr>
+                            <m:fName>
+                              <m:r>
+                                <m:rPr>
+                                  <m:sty m:val="p"/>
+                                </m:rPr>
+                                <a:rPr lang="en-US" b="0" i="0" smtClean="0">
+                                  <a:latin typeface="Cambria Math" panose="02040503050406030204" pitchFamily="18" charset="0"/>
+                                </a:rPr>
+                                <m:t>cos</m:t>
+                              </m:r>
+                            </m:fName>
+                            <m:e>
+                              <m:r>
+                                <a:rPr lang="en-US" b="0" i="1" smtClean="0">
+                                  <a:latin typeface="Cambria Math" panose="02040503050406030204" pitchFamily="18" charset="0"/>
+                                  <a:ea typeface="Cambria Math" panose="02040503050406030204" pitchFamily="18" charset="0"/>
+                                </a:rPr>
+                                <m:t>𝜃</m:t>
+                              </m:r>
+                            </m:e>
+                          </m:func>
+                        </m:den>
+                      </m:f>
+                      <m:r>
+                        <a:rPr lang="en-US" b="0" i="1" smtClean="0">
+                          <a:latin typeface="Cambria Math" panose="02040503050406030204" pitchFamily="18" charset="0"/>
+                        </a:rPr>
+                        <m:t>+</m:t>
+                      </m:r>
+                      <m:r>
+                        <a:rPr lang="en-US" b="0" i="1" smtClean="0">
+                          <a:latin typeface="Cambria Math" panose="02040503050406030204" pitchFamily="18" charset="0"/>
+                        </a:rPr>
+                        <m:t>𝑟</m:t>
+                      </m:r>
+                      <m:f>
+                        <m:fPr>
+                          <m:ctrlPr>
+                            <a:rPr lang="en-US" b="0" i="1" smtClean="0">
+                              <a:latin typeface="Cambria Math" panose="02040503050406030204" pitchFamily="18" charset="0"/>
+                            </a:rPr>
+                          </m:ctrlPr>
+                        </m:fPr>
+                        <m:num>
+                          <m:func>
+                            <m:funcPr>
+                              <m:ctrlPr>
+                                <a:rPr lang="en-US" b="0" i="1" smtClean="0">
+                                  <a:latin typeface="Cambria Math" panose="02040503050406030204" pitchFamily="18" charset="0"/>
+                                </a:rPr>
+                              </m:ctrlPr>
+                            </m:funcPr>
+                            <m:fName>
+                              <m:r>
+                                <m:rPr>
+                                  <m:sty m:val="p"/>
+                                </m:rPr>
+                                <a:rPr lang="en-US" b="0" i="0" smtClean="0">
+                                  <a:latin typeface="Cambria Math" panose="02040503050406030204" pitchFamily="18" charset="0"/>
+                                </a:rPr>
+                                <m:t>cos</m:t>
+                              </m:r>
+                            </m:fName>
+                            <m:e>
+                              <m:r>
+                                <a:rPr lang="en-US" b="0" i="1" smtClean="0">
+                                  <a:latin typeface="Cambria Math" panose="02040503050406030204" pitchFamily="18" charset="0"/>
+                                  <a:ea typeface="Cambria Math" panose="02040503050406030204" pitchFamily="18" charset="0"/>
+                                </a:rPr>
+                                <m:t>𝜙</m:t>
+                              </m:r>
+                            </m:e>
+                          </m:func>
+                        </m:num>
+                        <m:den>
+                          <m:func>
+                            <m:funcPr>
+                              <m:ctrlPr>
+                                <a:rPr lang="en-US" b="0" i="1" smtClean="0">
+                                  <a:latin typeface="Cambria Math" panose="02040503050406030204" pitchFamily="18" charset="0"/>
+                                </a:rPr>
+                              </m:ctrlPr>
+                            </m:funcPr>
+                            <m:fName>
+                              <m:r>
+                                <m:rPr>
+                                  <m:sty m:val="p"/>
+                                </m:rPr>
+                                <a:rPr lang="en-US" b="0" i="0" smtClean="0">
+                                  <a:latin typeface="Cambria Math" panose="02040503050406030204" pitchFamily="18" charset="0"/>
+                                </a:rPr>
+                                <m:t>cos</m:t>
+                              </m:r>
+                            </m:fName>
+                            <m:e>
+                              <m:r>
+                                <a:rPr lang="en-US" b="0" i="1" smtClean="0">
+                                  <a:latin typeface="Cambria Math" panose="02040503050406030204" pitchFamily="18" charset="0"/>
+                                  <a:ea typeface="Cambria Math" panose="02040503050406030204" pitchFamily="18" charset="0"/>
+                                </a:rPr>
+                                <m:t>𝜃</m:t>
+                              </m:r>
+                            </m:e>
+                          </m:func>
+                        </m:den>
+                      </m:f>
+                    </m:oMath>
+                  </m:oMathPara>
+                </a14:m>
+                <a:endParaRPr lang="en-US" dirty="0"/>
+              </a:p>
+              <a:p>
+                <a:pPr marL="0" indent="0">
+                  <a:buNone/>
+                </a:pPr>
+                <a:endParaRPr lang="en-US" sz="1200" dirty="0"/>
+              </a:p>
+              <a:p>
+                <a:pPr marL="0" indent="0">
+                  <a:buNone/>
+                </a:pPr>
+                <a14:m>
+                  <m:oMathPara xmlns:m="http://schemas.openxmlformats.org/officeDocument/2006/math">
+                    <m:oMathParaPr>
+                      <m:jc m:val="centerGroup"/>
+                    </m:oMathParaPr>
+                    <m:oMath xmlns:m="http://schemas.openxmlformats.org/officeDocument/2006/math">
+                      <m:acc>
+                        <m:accPr>
+                          <m:chr m:val="̇"/>
+                          <m:ctrlPr>
+                            <a:rPr lang="en-US" i="1" smtClean="0">
+                              <a:latin typeface="Cambria Math" panose="02040503050406030204" pitchFamily="18" charset="0"/>
+                            </a:rPr>
+                          </m:ctrlPr>
+                        </m:accPr>
+                        <m:e>
+                          <m:r>
+                            <a:rPr lang="en-US" i="1" smtClean="0">
+                              <a:latin typeface="Cambria Math" panose="02040503050406030204" pitchFamily="18" charset="0"/>
+                              <a:ea typeface="Cambria Math" panose="02040503050406030204" pitchFamily="18" charset="0"/>
+                            </a:rPr>
+                            <m:t>𝜙</m:t>
+                          </m:r>
+                        </m:e>
+                      </m:acc>
+                      <m:r>
+                        <a:rPr lang="en-US" b="0" i="1" smtClean="0">
+                          <a:latin typeface="Cambria Math" panose="02040503050406030204" pitchFamily="18" charset="0"/>
+                        </a:rPr>
+                        <m:t>=</m:t>
+                      </m:r>
+                      <m:r>
+                        <a:rPr lang="en-US" b="0" i="1" smtClean="0">
+                          <a:latin typeface="Cambria Math" panose="02040503050406030204" pitchFamily="18" charset="0"/>
+                        </a:rPr>
+                        <m:t>𝑝</m:t>
+                      </m:r>
+                      <m:r>
+                        <a:rPr lang="en-US" b="0" i="1" smtClean="0">
+                          <a:latin typeface="Cambria Math" panose="02040503050406030204" pitchFamily="18" charset="0"/>
+                        </a:rPr>
+                        <m:t>+</m:t>
+                      </m:r>
+                      <m:r>
+                        <a:rPr lang="en-US" b="0" i="1" smtClean="0">
+                          <a:latin typeface="Cambria Math" panose="02040503050406030204" pitchFamily="18" charset="0"/>
+                        </a:rPr>
+                        <m:t>𝑞</m:t>
+                      </m:r>
+                      <m:func>
+                        <m:funcPr>
+                          <m:ctrlPr>
+                            <a:rPr lang="en-US" b="0" i="1" smtClean="0">
+                              <a:latin typeface="Cambria Math" panose="02040503050406030204" pitchFamily="18" charset="0"/>
+                            </a:rPr>
+                          </m:ctrlPr>
+                        </m:funcPr>
+                        <m:fName>
+                          <m:r>
+                            <m:rPr>
+                              <m:sty m:val="p"/>
+                            </m:rPr>
+                            <a:rPr lang="en-US" b="0" i="0" smtClean="0">
+                              <a:latin typeface="Cambria Math" panose="02040503050406030204" pitchFamily="18" charset="0"/>
+                            </a:rPr>
+                            <m:t>sin</m:t>
+                          </m:r>
+                        </m:fName>
+                        <m:e>
+                          <m:r>
+                            <a:rPr lang="en-US" b="0" i="1" smtClean="0">
+                              <a:latin typeface="Cambria Math" panose="02040503050406030204" pitchFamily="18" charset="0"/>
+                              <a:ea typeface="Cambria Math" panose="02040503050406030204" pitchFamily="18" charset="0"/>
+                            </a:rPr>
+                            <m:t>𝜙</m:t>
+                          </m:r>
+                        </m:e>
+                      </m:func>
+                      <m:func>
+                        <m:funcPr>
+                          <m:ctrlPr>
+                            <a:rPr lang="en-US" b="0" i="1" smtClean="0">
+                              <a:latin typeface="Cambria Math" panose="02040503050406030204" pitchFamily="18" charset="0"/>
+                            </a:rPr>
+                          </m:ctrlPr>
+                        </m:funcPr>
+                        <m:fName>
+                          <m:r>
+                            <m:rPr>
+                              <m:sty m:val="p"/>
+                            </m:rPr>
+                            <a:rPr lang="en-US" b="0" i="0" smtClean="0">
+                              <a:latin typeface="Cambria Math" panose="02040503050406030204" pitchFamily="18" charset="0"/>
+                            </a:rPr>
+                            <m:t>tan</m:t>
+                          </m:r>
+                        </m:fName>
+                        <m:e>
+                          <m:r>
+                            <a:rPr lang="en-US" b="0" i="1" smtClean="0">
+                              <a:latin typeface="Cambria Math" panose="02040503050406030204" pitchFamily="18" charset="0"/>
+                              <a:ea typeface="Cambria Math" panose="02040503050406030204" pitchFamily="18" charset="0"/>
+                            </a:rPr>
+                            <m:t>𝜃</m:t>
+                          </m:r>
+                        </m:e>
+                      </m:func>
+                      <m:r>
+                        <a:rPr lang="en-US" b="0" i="1" smtClean="0">
+                          <a:latin typeface="Cambria Math" panose="02040503050406030204" pitchFamily="18" charset="0"/>
+                        </a:rPr>
+                        <m:t>+</m:t>
+                      </m:r>
+                      <m:r>
+                        <a:rPr lang="en-US" b="0" i="1" smtClean="0">
+                          <a:latin typeface="Cambria Math" panose="02040503050406030204" pitchFamily="18" charset="0"/>
+                        </a:rPr>
+                        <m:t>𝑟</m:t>
+                      </m:r>
+                      <m:func>
+                        <m:funcPr>
+                          <m:ctrlPr>
+                            <a:rPr lang="en-US" b="0" i="1" smtClean="0">
+                              <a:latin typeface="Cambria Math" panose="02040503050406030204" pitchFamily="18" charset="0"/>
+                            </a:rPr>
+                          </m:ctrlPr>
+                        </m:funcPr>
+                        <m:fName>
+                          <m:r>
+                            <m:rPr>
+                              <m:sty m:val="p"/>
+                            </m:rPr>
+                            <a:rPr lang="en-US" b="0" i="0" smtClean="0">
+                              <a:latin typeface="Cambria Math" panose="02040503050406030204" pitchFamily="18" charset="0"/>
+                            </a:rPr>
+                            <m:t>cos</m:t>
+                          </m:r>
+                        </m:fName>
+                        <m:e>
+                          <m:r>
+                            <a:rPr lang="en-US" b="0" i="1" smtClean="0">
+                              <a:latin typeface="Cambria Math" panose="02040503050406030204" pitchFamily="18" charset="0"/>
+                              <a:ea typeface="Cambria Math" panose="02040503050406030204" pitchFamily="18" charset="0"/>
+                            </a:rPr>
+                            <m:t>𝜙</m:t>
+                          </m:r>
+                        </m:e>
+                      </m:func>
+                      <m:func>
+                        <m:funcPr>
+                          <m:ctrlPr>
+                            <a:rPr lang="en-US" b="0" i="1" smtClean="0">
+                              <a:latin typeface="Cambria Math" panose="02040503050406030204" pitchFamily="18" charset="0"/>
+                            </a:rPr>
+                          </m:ctrlPr>
+                        </m:funcPr>
+                        <m:fName>
+                          <m:r>
+                            <m:rPr>
+                              <m:sty m:val="p"/>
+                            </m:rPr>
+                            <a:rPr lang="en-US" b="0" i="0" smtClean="0">
+                              <a:latin typeface="Cambria Math" panose="02040503050406030204" pitchFamily="18" charset="0"/>
+                            </a:rPr>
+                            <m:t>tan</m:t>
+                          </m:r>
+                        </m:fName>
+                        <m:e>
+                          <m:r>
+                            <a:rPr lang="en-US" b="0" i="1" smtClean="0">
+                              <a:latin typeface="Cambria Math" panose="02040503050406030204" pitchFamily="18" charset="0"/>
+                              <a:ea typeface="Cambria Math" panose="02040503050406030204" pitchFamily="18" charset="0"/>
+                            </a:rPr>
+                            <m:t>𝜃</m:t>
+                          </m:r>
+                        </m:e>
+                      </m:func>
+                    </m:oMath>
+                  </m:oMathPara>
+                </a14:m>
+                <a:endParaRPr lang="en-US" dirty="0"/>
+              </a:p>
+            </p:txBody>
+          </p:sp>
+        </mc:Choice>
+        <mc:Fallback>
+          <p:sp>
+            <p:nvSpPr>
+              <p:cNvPr id="3" name="Content Placeholder 2">
+                <a:extLst>
+                  <a:ext uri="{FF2B5EF4-FFF2-40B4-BE49-F238E27FC236}">
+                    <a16:creationId xmlns:a16="http://schemas.microsoft.com/office/drawing/2014/main" id="{A708DF32-6843-271E-385E-8FD16F2FEF16}"/>
+                  </a:ext>
+                </a:extLst>
+              </p:cNvPr>
+              <p:cNvSpPr>
+                <a:spLocks noGrp="1" noRot="1" noChangeAspect="1" noMove="1" noResize="1" noEditPoints="1" noAdjustHandles="1" noChangeArrowheads="1" noChangeShapeType="1" noTextEdit="1"/>
+              </p:cNvSpPr>
+              <p:nvPr>
+                <p:ph idx="1"/>
+              </p:nvPr>
+            </p:nvSpPr>
+            <p:spPr>
+              <a:xfrm>
+                <a:off x="441036" y="1262207"/>
+                <a:ext cx="6001882" cy="4351338"/>
+              </a:xfrm>
+              <a:blipFill>
+                <a:blip r:embed="rId2"/>
+                <a:stretch>
+                  <a:fillRect t="-1541"/>
+                </a:stretch>
+              </a:blipFill>
+            </p:spPr>
+            <p:txBody>
+              <a:bodyPr/>
+              <a:lstStyle/>
+              <a:p>
+                <a:r>
+                  <a:rPr lang="en-US">
+                    <a:noFill/>
+                  </a:rPr>
+                  <a:t> </a:t>
+                </a:r>
+              </a:p>
+            </p:txBody>
+          </p:sp>
+        </mc:Fallback>
+      </mc:AlternateContent>
+      <p:sp>
+        <p:nvSpPr>
+          <p:cNvPr id="4" name="Oval 3">
+            <a:extLst>
+              <a:ext uri="{FF2B5EF4-FFF2-40B4-BE49-F238E27FC236}">
+                <a16:creationId xmlns:a16="http://schemas.microsoft.com/office/drawing/2014/main" id="{0BA26F9F-969F-2B79-0BDC-315A5D18984C}"/>
+              </a:ext>
+            </a:extLst>
+          </p:cNvPr>
+          <p:cNvSpPr/>
+          <p:nvPr/>
+        </p:nvSpPr>
+        <p:spPr>
+          <a:xfrm>
+            <a:off x="2762226" y="2384210"/>
+            <a:ext cx="905256" cy="502920"/>
+          </a:xfrm>
+          <a:prstGeom prst="ellipse">
+            <a:avLst/>
+          </a:prstGeom>
+          <a:noFill/>
+          <a:ln w="25400">
+            <a:solidFill>
+              <a:srgbClr val="FF0000"/>
+            </a:solidFill>
+          </a:ln>
+        </p:spPr>
+        <p:style>
+          <a:lnRef idx="2">
+            <a:schemeClr val="accent1">
+              <a:shade val="15000"/>
+            </a:schemeClr>
+          </a:lnRef>
+          <a:fillRef idx="1">
+            <a:schemeClr val="accent1"/>
+          </a:fillRef>
+          <a:effectRef idx="0">
+            <a:schemeClr val="accent1"/>
+          </a:effectRef>
+          <a:fontRef idx="minor">
+            <a:schemeClr val="lt1"/>
+          </a:fontRef>
+        </p:style>
+        <p:txBody>
+          <a:bodyPr rtlCol="0" anchor="ctr"/>
+          <a:lstStyle/>
+          <a:p>
+            <a:pPr algn="ctr"/>
+            <a:endParaRPr lang="en-US"/>
+          </a:p>
+        </p:txBody>
+      </p:sp>
+      <p:sp>
+        <p:nvSpPr>
+          <p:cNvPr id="5" name="Oval 4">
+            <a:extLst>
+              <a:ext uri="{FF2B5EF4-FFF2-40B4-BE49-F238E27FC236}">
+                <a16:creationId xmlns:a16="http://schemas.microsoft.com/office/drawing/2014/main" id="{F2169BF2-DB05-CE05-702C-D00C1CCBD36F}"/>
+              </a:ext>
+            </a:extLst>
+          </p:cNvPr>
+          <p:cNvSpPr/>
+          <p:nvPr/>
+        </p:nvSpPr>
+        <p:spPr>
+          <a:xfrm>
+            <a:off x="4198481" y="2384210"/>
+            <a:ext cx="905256" cy="502920"/>
+          </a:xfrm>
+          <a:prstGeom prst="ellipse">
+            <a:avLst/>
+          </a:prstGeom>
+          <a:noFill/>
+          <a:ln w="25400">
+            <a:solidFill>
+              <a:srgbClr val="FF0000"/>
+            </a:solidFill>
+          </a:ln>
+        </p:spPr>
+        <p:style>
+          <a:lnRef idx="2">
+            <a:schemeClr val="accent1">
+              <a:shade val="15000"/>
+            </a:schemeClr>
+          </a:lnRef>
+          <a:fillRef idx="1">
+            <a:schemeClr val="accent1"/>
+          </a:fillRef>
+          <a:effectRef idx="0">
+            <a:schemeClr val="accent1"/>
+          </a:effectRef>
+          <a:fontRef idx="minor">
+            <a:schemeClr val="lt1"/>
+          </a:fontRef>
+        </p:style>
+        <p:txBody>
+          <a:bodyPr rtlCol="0" anchor="ctr"/>
+          <a:lstStyle/>
+          <a:p>
+            <a:pPr algn="ctr"/>
+            <a:endParaRPr lang="en-US"/>
+          </a:p>
+        </p:txBody>
+      </p:sp>
+      <p:sp>
+        <p:nvSpPr>
+          <p:cNvPr id="6" name="Oval 5">
+            <a:extLst>
+              <a:ext uri="{FF2B5EF4-FFF2-40B4-BE49-F238E27FC236}">
+                <a16:creationId xmlns:a16="http://schemas.microsoft.com/office/drawing/2014/main" id="{8B8D0496-FCB5-CE0E-65D8-A4F5A6B8512D}"/>
+              </a:ext>
+            </a:extLst>
+          </p:cNvPr>
+          <p:cNvSpPr/>
+          <p:nvPr/>
+        </p:nvSpPr>
+        <p:spPr>
+          <a:xfrm>
+            <a:off x="3053172" y="2948696"/>
+            <a:ext cx="905256" cy="502920"/>
+          </a:xfrm>
+          <a:prstGeom prst="ellipse">
+            <a:avLst/>
+          </a:prstGeom>
+          <a:noFill/>
+          <a:ln w="25400">
+            <a:solidFill>
+              <a:srgbClr val="FF0000"/>
+            </a:solidFill>
+          </a:ln>
+        </p:spPr>
+        <p:style>
+          <a:lnRef idx="2">
+            <a:schemeClr val="accent1">
+              <a:shade val="15000"/>
+            </a:schemeClr>
+          </a:lnRef>
+          <a:fillRef idx="1">
+            <a:schemeClr val="accent1"/>
+          </a:fillRef>
+          <a:effectRef idx="0">
+            <a:schemeClr val="accent1"/>
+          </a:effectRef>
+          <a:fontRef idx="minor">
+            <a:schemeClr val="lt1"/>
+          </a:fontRef>
+        </p:style>
+        <p:txBody>
+          <a:bodyPr rtlCol="0" anchor="ctr"/>
+          <a:lstStyle/>
+          <a:p>
+            <a:pPr algn="ctr"/>
+            <a:endParaRPr lang="en-US"/>
+          </a:p>
+        </p:txBody>
+      </p:sp>
+      <p:sp>
+        <p:nvSpPr>
+          <p:cNvPr id="7" name="Oval 6">
+            <a:extLst>
+              <a:ext uri="{FF2B5EF4-FFF2-40B4-BE49-F238E27FC236}">
+                <a16:creationId xmlns:a16="http://schemas.microsoft.com/office/drawing/2014/main" id="{CA75A0B5-B528-1764-8D7A-7E6EC89FF589}"/>
+              </a:ext>
+            </a:extLst>
+          </p:cNvPr>
+          <p:cNvSpPr/>
+          <p:nvPr/>
+        </p:nvSpPr>
+        <p:spPr>
+          <a:xfrm>
+            <a:off x="5357644" y="2948696"/>
+            <a:ext cx="905256" cy="502920"/>
+          </a:xfrm>
+          <a:prstGeom prst="ellipse">
+            <a:avLst/>
+          </a:prstGeom>
+          <a:noFill/>
+          <a:ln w="25400">
+            <a:solidFill>
+              <a:srgbClr val="FF0000"/>
+            </a:solidFill>
+          </a:ln>
+        </p:spPr>
+        <p:style>
+          <a:lnRef idx="2">
+            <a:schemeClr val="accent1">
+              <a:shade val="15000"/>
+            </a:schemeClr>
+          </a:lnRef>
+          <a:fillRef idx="1">
+            <a:schemeClr val="accent1"/>
+          </a:fillRef>
+          <a:effectRef idx="0">
+            <a:schemeClr val="accent1"/>
+          </a:effectRef>
+          <a:fontRef idx="minor">
+            <a:schemeClr val="lt1"/>
+          </a:fontRef>
+        </p:style>
+        <p:txBody>
+          <a:bodyPr rtlCol="0" anchor="ctr"/>
+          <a:lstStyle/>
+          <a:p>
+            <a:pPr algn="ctr"/>
+            <a:endParaRPr lang="en-US"/>
+          </a:p>
+        </p:txBody>
+      </p:sp>
+      <mc:AlternateContent xmlns:mc="http://schemas.openxmlformats.org/markup-compatibility/2006">
+        <mc:Choice xmlns:a14="http://schemas.microsoft.com/office/drawing/2010/main" Requires="a14">
+          <p:sp>
+            <p:nvSpPr>
+              <p:cNvPr id="8" name="TextBox 7">
+                <a:extLst>
+                  <a:ext uri="{FF2B5EF4-FFF2-40B4-BE49-F238E27FC236}">
+                    <a16:creationId xmlns:a16="http://schemas.microsoft.com/office/drawing/2014/main" id="{D883F520-EE07-64B8-A588-7A2FCF841BA1}"/>
+                  </a:ext>
+                </a:extLst>
+              </p:cNvPr>
+              <p:cNvSpPr txBox="1"/>
+              <p:nvPr/>
+            </p:nvSpPr>
+            <p:spPr>
+              <a:xfrm>
+                <a:off x="8238836" y="440171"/>
+                <a:ext cx="3389746" cy="2031325"/>
+              </a:xfrm>
+              <a:prstGeom prst="rect">
+                <a:avLst/>
+              </a:prstGeom>
+              <a:noFill/>
+            </p:spPr>
+            <p:txBody>
+              <a:bodyPr wrap="square" rtlCol="0">
+                <a:spAutoFit/>
+              </a:bodyPr>
+              <a:lstStyle/>
+              <a:p>
+                <a:pPr/>
+                <a14:m>
+                  <m:oMath xmlns:m="http://schemas.openxmlformats.org/officeDocument/2006/math">
+                    <m:r>
+                      <a:rPr lang="en-US" i="1">
+                        <a:latin typeface="Cambria Math" panose="02040503050406030204" pitchFamily="18" charset="0"/>
+                        <a:ea typeface="Cambria Math" panose="02040503050406030204" pitchFamily="18" charset="0"/>
+                      </a:rPr>
+                      <m:t>𝜙</m:t>
+                    </m:r>
+                  </m:oMath>
+                </a14:m>
+                <a:r>
+                  <a:rPr lang="en-US" dirty="0"/>
+                  <a:t>  roll</a:t>
+                </a:r>
+              </a:p>
+              <a:p>
+                <a:pPr/>
+                <a14:m>
+                  <m:oMath xmlns:m="http://schemas.openxmlformats.org/officeDocument/2006/math">
+                    <m:r>
+                      <a:rPr lang="en-US" i="1" smtClean="0">
+                        <a:latin typeface="Cambria Math" panose="02040503050406030204" pitchFamily="18" charset="0"/>
+                        <a:ea typeface="Cambria Math" panose="02040503050406030204" pitchFamily="18" charset="0"/>
+                      </a:rPr>
+                      <m:t>𝜃</m:t>
+                    </m:r>
+                  </m:oMath>
+                </a14:m>
+                <a:r>
+                  <a:rPr lang="en-US" dirty="0">
+                    <a:ea typeface="Cambria Math" panose="02040503050406030204" pitchFamily="18" charset="0"/>
+                  </a:rPr>
+                  <a:t>  pitch</a:t>
+                </a:r>
+              </a:p>
+              <a:p>
+                <a:pPr/>
+                <a14:m>
+                  <m:oMath xmlns:m="http://schemas.openxmlformats.org/officeDocument/2006/math">
+                    <m:r>
+                      <a:rPr lang="en-US" i="1">
+                        <a:latin typeface="Cambria Math" panose="02040503050406030204" pitchFamily="18" charset="0"/>
+                        <a:ea typeface="Cambria Math" panose="02040503050406030204" pitchFamily="18" charset="0"/>
+                      </a:rPr>
+                      <m:t>𝜓</m:t>
+                    </m:r>
+                  </m:oMath>
+                </a14:m>
+                <a:r>
+                  <a:rPr lang="en-US" dirty="0">
+                    <a:ea typeface="Cambria Math" panose="02040503050406030204" pitchFamily="18" charset="0"/>
+                  </a:rPr>
+                  <a:t>  yaw</a:t>
+                </a:r>
+              </a:p>
+              <a:p>
+                <a:pPr/>
+                <a:endParaRPr lang="en-US" dirty="0"/>
+              </a:p>
+              <a:p>
+                <a:pPr/>
+                <a14:m>
+                  <m:oMath xmlns:m="http://schemas.openxmlformats.org/officeDocument/2006/math">
+                    <m:r>
+                      <a:rPr lang="en-US" b="0" i="1" smtClean="0">
+                        <a:latin typeface="Cambria Math" panose="02040503050406030204" pitchFamily="18" charset="0"/>
+                      </a:rPr>
+                      <m:t>𝑝</m:t>
+                    </m:r>
+                  </m:oMath>
+                </a14:m>
+                <a:r>
+                  <a:rPr lang="en-US" b="0" dirty="0"/>
+                  <a:t>  body axis roll rate</a:t>
+                </a:r>
+              </a:p>
+              <a:p>
+                <a:pPr/>
+                <a14:m>
+                  <m:oMath xmlns:m="http://schemas.openxmlformats.org/officeDocument/2006/math">
+                    <m:r>
+                      <a:rPr lang="en-US" b="0" i="1" smtClean="0">
+                        <a:latin typeface="Cambria Math" panose="02040503050406030204" pitchFamily="18" charset="0"/>
+                      </a:rPr>
+                      <m:t>𝑞</m:t>
+                    </m:r>
+                  </m:oMath>
+                </a14:m>
+                <a:r>
+                  <a:rPr lang="en-US" b="0" dirty="0"/>
+                  <a:t>  body axis pitch rate</a:t>
+                </a:r>
+              </a:p>
+              <a:p>
+                <a:pPr/>
+                <a14:m>
+                  <m:oMath xmlns:m="http://schemas.openxmlformats.org/officeDocument/2006/math">
+                    <m:r>
+                      <a:rPr lang="en-US" b="0" i="1" smtClean="0">
+                        <a:latin typeface="Cambria Math" panose="02040503050406030204" pitchFamily="18" charset="0"/>
+                      </a:rPr>
+                      <m:t>𝑟</m:t>
+                    </m:r>
+                  </m:oMath>
+                </a14:m>
+                <a:r>
+                  <a:rPr lang="en-US" dirty="0"/>
+                  <a:t>  body axis yaw rate</a:t>
+                </a:r>
+              </a:p>
+            </p:txBody>
+          </p:sp>
+        </mc:Choice>
+        <mc:Fallback>
+          <p:sp>
+            <p:nvSpPr>
+              <p:cNvPr id="8" name="TextBox 7">
+                <a:extLst>
+                  <a:ext uri="{FF2B5EF4-FFF2-40B4-BE49-F238E27FC236}">
+                    <a16:creationId xmlns:a16="http://schemas.microsoft.com/office/drawing/2014/main" id="{D883F520-EE07-64B8-A588-7A2FCF841BA1}"/>
+                  </a:ext>
+                </a:extLst>
+              </p:cNvPr>
+              <p:cNvSpPr txBox="1">
+                <a:spLocks noRot="1" noChangeAspect="1" noMove="1" noResize="1" noEditPoints="1" noAdjustHandles="1" noChangeArrowheads="1" noChangeShapeType="1" noTextEdit="1"/>
+              </p:cNvSpPr>
+              <p:nvPr/>
+            </p:nvSpPr>
+            <p:spPr>
+              <a:xfrm>
+                <a:off x="8238836" y="440171"/>
+                <a:ext cx="3389746" cy="2031325"/>
+              </a:xfrm>
+              <a:prstGeom prst="rect">
+                <a:avLst/>
+              </a:prstGeom>
+              <a:blipFill>
+                <a:blip r:embed="rId3"/>
+                <a:stretch>
+                  <a:fillRect l="-540" t="-1201" b="-4204"/>
+                </a:stretch>
+              </a:blipFill>
+            </p:spPr>
+            <p:txBody>
+              <a:bodyPr/>
+              <a:lstStyle/>
+              <a:p>
+                <a:r>
+                  <a:rPr lang="en-US">
+                    <a:noFill/>
+                  </a:rPr>
+                  <a:t> </a:t>
+                </a:r>
+              </a:p>
+            </p:txBody>
+          </p:sp>
+        </mc:Fallback>
+      </mc:AlternateContent>
+      <mc:AlternateContent xmlns:mc="http://schemas.openxmlformats.org/markup-compatibility/2006">
+        <mc:Choice xmlns:a14="http://schemas.microsoft.com/office/drawing/2010/main" Requires="a14">
+          <p:sp>
+            <p:nvSpPr>
+              <p:cNvPr id="9" name="TextBox 8">
+                <a:extLst>
+                  <a:ext uri="{FF2B5EF4-FFF2-40B4-BE49-F238E27FC236}">
+                    <a16:creationId xmlns:a16="http://schemas.microsoft.com/office/drawing/2014/main" id="{5A2EC155-436A-19B8-D2C6-094A76AF7C67}"/>
+                  </a:ext>
+                </a:extLst>
+              </p:cNvPr>
+              <p:cNvSpPr txBox="1"/>
+              <p:nvPr/>
+            </p:nvSpPr>
+            <p:spPr>
+              <a:xfrm>
+                <a:off x="662985" y="4604558"/>
+                <a:ext cx="6677891" cy="663836"/>
+              </a:xfrm>
+              <a:prstGeom prst="rect">
+                <a:avLst/>
+              </a:prstGeom>
+              <a:noFill/>
+            </p:spPr>
+            <p:txBody>
+              <a:bodyPr wrap="square" rtlCol="0">
+                <a:spAutoFit/>
+              </a:bodyPr>
+              <a:lstStyle/>
+              <a:p>
+                <a:r>
+                  <a:rPr lang="en-US" sz="2800" dirty="0"/>
+                  <a:t>When </a:t>
+                </a:r>
+                <a14:m>
+                  <m:oMath xmlns:m="http://schemas.openxmlformats.org/officeDocument/2006/math">
+                    <m:r>
+                      <a:rPr lang="en-US" sz="2800" i="1" smtClean="0">
+                        <a:latin typeface="Cambria Math" panose="02040503050406030204" pitchFamily="18" charset="0"/>
+                        <a:ea typeface="Cambria Math" panose="02040503050406030204" pitchFamily="18" charset="0"/>
+                      </a:rPr>
+                      <m:t>𝜃</m:t>
+                    </m:r>
+                  </m:oMath>
+                </a14:m>
+                <a:r>
+                  <a:rPr lang="en-US" sz="2800" dirty="0"/>
+                  <a:t> hits </a:t>
+                </a:r>
+                <a14:m>
+                  <m:oMath xmlns:m="http://schemas.openxmlformats.org/officeDocument/2006/math">
+                    <m:r>
+                      <a:rPr lang="en-US" sz="2800" b="0" i="1" smtClean="0">
+                        <a:latin typeface="Cambria Math" panose="02040503050406030204" pitchFamily="18" charset="0"/>
+                      </a:rPr>
+                      <m:t>±</m:t>
+                    </m:r>
+                    <m:f>
+                      <m:fPr>
+                        <m:ctrlPr>
+                          <a:rPr lang="en-US" sz="2800" b="0" i="1" smtClean="0">
+                            <a:latin typeface="Cambria Math" panose="02040503050406030204" pitchFamily="18" charset="0"/>
+                          </a:rPr>
+                        </m:ctrlPr>
+                      </m:fPr>
+                      <m:num>
+                        <m:r>
+                          <a:rPr lang="en-US" sz="2800" b="0" i="1" smtClean="0">
+                            <a:latin typeface="Cambria Math" panose="02040503050406030204" pitchFamily="18" charset="0"/>
+                            <a:ea typeface="Cambria Math" panose="02040503050406030204" pitchFamily="18" charset="0"/>
+                          </a:rPr>
+                          <m:t>𝜋</m:t>
+                        </m:r>
+                      </m:num>
+                      <m:den>
+                        <m:r>
+                          <a:rPr lang="en-US" sz="2800" b="0" i="1" smtClean="0">
+                            <a:latin typeface="Cambria Math" panose="02040503050406030204" pitchFamily="18" charset="0"/>
+                          </a:rPr>
+                          <m:t>2</m:t>
+                        </m:r>
+                      </m:den>
+                    </m:f>
+                  </m:oMath>
+                </a14:m>
+                <a:r>
+                  <a:rPr lang="en-US" sz="2800" dirty="0"/>
+                  <a:t>, we get singularities here</a:t>
+                </a:r>
+              </a:p>
+            </p:txBody>
+          </p:sp>
+        </mc:Choice>
+        <mc:Fallback>
+          <p:sp>
+            <p:nvSpPr>
+              <p:cNvPr id="9" name="TextBox 8">
+                <a:extLst>
+                  <a:ext uri="{FF2B5EF4-FFF2-40B4-BE49-F238E27FC236}">
+                    <a16:creationId xmlns:a16="http://schemas.microsoft.com/office/drawing/2014/main" id="{5A2EC155-436A-19B8-D2C6-094A76AF7C67}"/>
+                  </a:ext>
+                </a:extLst>
+              </p:cNvPr>
+              <p:cNvSpPr txBox="1">
+                <a:spLocks noRot="1" noChangeAspect="1" noMove="1" noResize="1" noEditPoints="1" noAdjustHandles="1" noChangeArrowheads="1" noChangeShapeType="1" noTextEdit="1"/>
+              </p:cNvSpPr>
+              <p:nvPr/>
+            </p:nvSpPr>
+            <p:spPr>
+              <a:xfrm>
+                <a:off x="662985" y="4604558"/>
+                <a:ext cx="6677891" cy="663836"/>
+              </a:xfrm>
+              <a:prstGeom prst="rect">
+                <a:avLst/>
+              </a:prstGeom>
+              <a:blipFill>
+                <a:blip r:embed="rId4"/>
+                <a:stretch>
+                  <a:fillRect l="-1918" b="-12844"/>
+                </a:stretch>
+              </a:blipFill>
+            </p:spPr>
+            <p:txBody>
+              <a:bodyPr/>
+              <a:lstStyle/>
+              <a:p>
+                <a:r>
+                  <a:rPr lang="en-US">
+                    <a:noFill/>
+                  </a:rPr>
+                  <a:t> </a:t>
+                </a:r>
+              </a:p>
+            </p:txBody>
+          </p:sp>
+        </mc:Fallback>
+      </mc:AlternateContent>
+      <mc:AlternateContent xmlns:mc="http://schemas.openxmlformats.org/markup-compatibility/2006">
+        <mc:Choice xmlns:a14="http://schemas.microsoft.com/office/drawing/2010/main" Requires="a14">
+          <p:sp>
+            <p:nvSpPr>
+              <p:cNvPr id="10" name="TextBox 9">
+                <a:extLst>
+                  <a:ext uri="{FF2B5EF4-FFF2-40B4-BE49-F238E27FC236}">
+                    <a16:creationId xmlns:a16="http://schemas.microsoft.com/office/drawing/2014/main" id="{EB966C09-2500-4083-33B2-98A381D0B5AD}"/>
+                  </a:ext>
+                </a:extLst>
+              </p:cNvPr>
+              <p:cNvSpPr txBox="1"/>
+              <p:nvPr/>
+            </p:nvSpPr>
+            <p:spPr>
+              <a:xfrm>
+                <a:off x="662984" y="5268394"/>
+                <a:ext cx="6677891" cy="1425134"/>
+              </a:xfrm>
+              <a:prstGeom prst="rect">
+                <a:avLst/>
+              </a:prstGeom>
+              <a:noFill/>
+            </p:spPr>
+            <p:txBody>
+              <a:bodyPr wrap="square" rtlCol="0">
+                <a:spAutoFit/>
+              </a:bodyPr>
+              <a:lstStyle/>
+              <a:p>
+                <a14:m>
+                  <m:oMath xmlns:m="http://schemas.openxmlformats.org/officeDocument/2006/math">
+                    <m:acc>
+                      <m:accPr>
+                        <m:chr m:val="̇"/>
+                        <m:ctrlPr>
+                          <a:rPr lang="en-US" sz="2800" i="1" smtClean="0">
+                            <a:latin typeface="Cambria Math" panose="02040503050406030204" pitchFamily="18" charset="0"/>
+                          </a:rPr>
+                        </m:ctrlPr>
+                      </m:accPr>
+                      <m:e>
+                        <m:r>
+                          <a:rPr lang="en-US" sz="2800" i="1" smtClean="0">
+                            <a:latin typeface="Cambria Math" panose="02040503050406030204" pitchFamily="18" charset="0"/>
+                            <a:ea typeface="Cambria Math" panose="02040503050406030204" pitchFamily="18" charset="0"/>
+                          </a:rPr>
+                          <m:t>𝜃</m:t>
+                        </m:r>
+                      </m:e>
+                    </m:acc>
+                  </m:oMath>
+                </a14:m>
+                <a:r>
+                  <a:rPr lang="en-US" sz="2800" dirty="0"/>
+                  <a:t> is fine</a:t>
+                </a:r>
+              </a:p>
+              <a:p>
+                <a14:m>
+                  <m:oMath xmlns:m="http://schemas.openxmlformats.org/officeDocument/2006/math">
+                    <m:acc>
+                      <m:accPr>
+                        <m:chr m:val="̇"/>
+                        <m:ctrlPr>
+                          <a:rPr lang="en-US" sz="2800" i="1" smtClean="0">
+                            <a:latin typeface="Cambria Math" panose="02040503050406030204" pitchFamily="18" charset="0"/>
+                          </a:rPr>
+                        </m:ctrlPr>
+                      </m:accPr>
+                      <m:e>
+                        <m:r>
+                          <a:rPr lang="en-US" sz="2800" i="1" smtClean="0">
+                            <a:latin typeface="Cambria Math" panose="02040503050406030204" pitchFamily="18" charset="0"/>
+                            <a:ea typeface="Cambria Math" panose="02040503050406030204" pitchFamily="18" charset="0"/>
+                          </a:rPr>
+                          <m:t>𝜙</m:t>
+                        </m:r>
+                      </m:e>
+                    </m:acc>
+                  </m:oMath>
+                </a14:m>
+                <a:r>
+                  <a:rPr lang="en-US" sz="2800" dirty="0"/>
+                  <a:t> and </a:t>
+                </a:r>
+                <a14:m>
+                  <m:oMath xmlns:m="http://schemas.openxmlformats.org/officeDocument/2006/math">
+                    <m:acc>
+                      <m:accPr>
+                        <m:chr m:val="̇"/>
+                        <m:ctrlPr>
+                          <a:rPr lang="en-US" sz="2800" i="1" smtClean="0">
+                            <a:latin typeface="Cambria Math" panose="02040503050406030204" pitchFamily="18" charset="0"/>
+                          </a:rPr>
+                        </m:ctrlPr>
+                      </m:accPr>
+                      <m:e>
+                        <m:r>
+                          <a:rPr lang="en-US" sz="2800" i="1" smtClean="0">
+                            <a:latin typeface="Cambria Math" panose="02040503050406030204" pitchFamily="18" charset="0"/>
+                            <a:ea typeface="Cambria Math" panose="02040503050406030204" pitchFamily="18" charset="0"/>
+                          </a:rPr>
+                          <m:t>𝜓</m:t>
+                        </m:r>
+                      </m:e>
+                    </m:acc>
+                  </m:oMath>
+                </a14:m>
+                <a:r>
+                  <a:rPr lang="en-US" sz="2800" dirty="0"/>
+                  <a:t> approach infinity</a:t>
+                </a:r>
+              </a:p>
+              <a:p>
+                <a14:m>
+                  <m:oMath xmlns:m="http://schemas.openxmlformats.org/officeDocument/2006/math">
+                    <m:r>
+                      <a:rPr lang="en-US" sz="2800" i="1" smtClean="0">
+                        <a:latin typeface="Cambria Math" panose="02040503050406030204" pitchFamily="18" charset="0"/>
+                        <a:ea typeface="Cambria Math" panose="02040503050406030204" pitchFamily="18" charset="0"/>
+                      </a:rPr>
+                      <m:t>𝜙</m:t>
+                    </m:r>
+                  </m:oMath>
+                </a14:m>
+                <a:r>
+                  <a:rPr lang="en-US" sz="2800" dirty="0"/>
+                  <a:t> and </a:t>
+                </a:r>
+                <a14:m>
+                  <m:oMath xmlns:m="http://schemas.openxmlformats.org/officeDocument/2006/math">
+                    <m:r>
+                      <a:rPr lang="en-US" sz="2800" i="1" smtClean="0">
+                        <a:latin typeface="Cambria Math" panose="02040503050406030204" pitchFamily="18" charset="0"/>
+                        <a:ea typeface="Cambria Math" panose="02040503050406030204" pitchFamily="18" charset="0"/>
+                      </a:rPr>
+                      <m:t>𝜓</m:t>
+                    </m:r>
+                  </m:oMath>
+                </a14:m>
+                <a:r>
+                  <a:rPr lang="en-US" sz="2800" dirty="0"/>
+                  <a:t> are discontinuous</a:t>
+                </a:r>
+              </a:p>
+            </p:txBody>
+          </p:sp>
+        </mc:Choice>
+        <mc:Fallback>
+          <p:sp>
+            <p:nvSpPr>
+              <p:cNvPr id="10" name="TextBox 9">
+                <a:extLst>
+                  <a:ext uri="{FF2B5EF4-FFF2-40B4-BE49-F238E27FC236}">
+                    <a16:creationId xmlns:a16="http://schemas.microsoft.com/office/drawing/2014/main" id="{EB966C09-2500-4083-33B2-98A381D0B5AD}"/>
+                  </a:ext>
+                </a:extLst>
+              </p:cNvPr>
+              <p:cNvSpPr txBox="1">
+                <a:spLocks noRot="1" noChangeAspect="1" noMove="1" noResize="1" noEditPoints="1" noAdjustHandles="1" noChangeArrowheads="1" noChangeShapeType="1" noTextEdit="1"/>
+              </p:cNvSpPr>
+              <p:nvPr/>
+            </p:nvSpPr>
+            <p:spPr>
+              <a:xfrm>
+                <a:off x="662984" y="5268394"/>
+                <a:ext cx="6677891" cy="1425134"/>
+              </a:xfrm>
+              <a:prstGeom prst="rect">
+                <a:avLst/>
+              </a:prstGeom>
+              <a:blipFill>
+                <a:blip r:embed="rId5"/>
+                <a:stretch>
+                  <a:fillRect t="-2564" b="-11111"/>
+                </a:stretch>
+              </a:blipFill>
+            </p:spPr>
+            <p:txBody>
+              <a:bodyPr/>
+              <a:lstStyle/>
+              <a:p>
+                <a:r>
+                  <a:rPr lang="en-US">
+                    <a:noFill/>
+                  </a:rPr>
+                  <a:t> </a:t>
+                </a:r>
+              </a:p>
+            </p:txBody>
+          </p:sp>
+        </mc:Fallback>
+      </mc:AlternateContent>
+      <p:pic>
+        <p:nvPicPr>
+          <p:cNvPr id="12" name="Picture 11">
+            <a:extLst>
+              <a:ext uri="{FF2B5EF4-FFF2-40B4-BE49-F238E27FC236}">
+                <a16:creationId xmlns:a16="http://schemas.microsoft.com/office/drawing/2014/main" id="{F24FA0E5-D397-FF5C-9FDF-D4FFA7AB4755}"/>
+              </a:ext>
+            </a:extLst>
+          </p:cNvPr>
+          <p:cNvPicPr>
+            <a:picLocks noChangeAspect="1"/>
+          </p:cNvPicPr>
+          <p:nvPr/>
+        </p:nvPicPr>
+        <p:blipFill>
+          <a:blip r:embed="rId6"/>
+          <a:stretch>
+            <a:fillRect/>
+          </a:stretch>
+        </p:blipFill>
+        <p:spPr>
+          <a:xfrm>
+            <a:off x="8039099" y="2615840"/>
+            <a:ext cx="3789219" cy="3959859"/>
+          </a:xfrm>
+          <a:prstGeom prst="rect">
+            <a:avLst/>
+          </a:prstGeom>
+        </p:spPr>
+      </p:pic>
+      <p:sp>
+        <p:nvSpPr>
+          <p:cNvPr id="13" name="TextBox 12">
+            <a:extLst>
+              <a:ext uri="{FF2B5EF4-FFF2-40B4-BE49-F238E27FC236}">
+                <a16:creationId xmlns:a16="http://schemas.microsoft.com/office/drawing/2014/main" id="{15347251-8ACF-E5A0-5FDF-7A05E168E62E}"/>
+              </a:ext>
+            </a:extLst>
+          </p:cNvPr>
+          <p:cNvSpPr txBox="1"/>
+          <p:nvPr/>
+        </p:nvSpPr>
+        <p:spPr>
+          <a:xfrm>
+            <a:off x="756550" y="264218"/>
+            <a:ext cx="5821864" cy="707886"/>
+          </a:xfrm>
+          <a:prstGeom prst="rect">
+            <a:avLst/>
+          </a:prstGeom>
+          <a:noFill/>
+        </p:spPr>
+        <p:txBody>
+          <a:bodyPr wrap="square" rtlCol="0">
+            <a:spAutoFit/>
+          </a:bodyPr>
+          <a:lstStyle/>
+          <a:p>
+            <a:pPr algn="ctr"/>
+            <a:r>
+              <a:rPr lang="en-US" sz="4000" dirty="0"/>
+              <a:t>Gimbal Lock</a:t>
+            </a:r>
+          </a:p>
+        </p:txBody>
+      </p:sp>
+      <p:cxnSp>
+        <p:nvCxnSpPr>
+          <p:cNvPr id="15" name="Straight Arrow Connector 14">
+            <a:extLst>
+              <a:ext uri="{FF2B5EF4-FFF2-40B4-BE49-F238E27FC236}">
+                <a16:creationId xmlns:a16="http://schemas.microsoft.com/office/drawing/2014/main" id="{71323F66-D1AD-E8A6-C369-639D5176FBDE}"/>
+              </a:ext>
+            </a:extLst>
+          </p:cNvPr>
+          <p:cNvCxnSpPr>
+            <a:cxnSpLocks/>
+            <a:endCxn id="4" idx="5"/>
+          </p:cNvCxnSpPr>
+          <p:nvPr/>
+        </p:nvCxnSpPr>
+        <p:spPr>
+          <a:xfrm flipH="1" flipV="1">
+            <a:off x="3534910" y="2813479"/>
+            <a:ext cx="2950654" cy="1894812"/>
+          </a:xfrm>
+          <a:prstGeom prst="straightConnector1">
+            <a:avLst/>
+          </a:prstGeom>
+          <a:ln w="25400">
+            <a:solidFill>
+              <a:srgbClr val="FF0000"/>
+            </a:solidFill>
+            <a:tailEnd type="triangle" w="lg" len="lg"/>
+          </a:ln>
+        </p:spPr>
+        <p:style>
+          <a:lnRef idx="2">
+            <a:schemeClr val="accent1"/>
+          </a:lnRef>
+          <a:fillRef idx="0">
+            <a:schemeClr val="accent1"/>
+          </a:fillRef>
+          <a:effectRef idx="1">
+            <a:schemeClr val="accent1"/>
+          </a:effectRef>
+          <a:fontRef idx="minor">
+            <a:schemeClr val="tx1"/>
+          </a:fontRef>
+        </p:style>
+      </p:cxnSp>
+      <p:cxnSp>
+        <p:nvCxnSpPr>
+          <p:cNvPr id="16" name="Straight Arrow Connector 15">
+            <a:extLst>
+              <a:ext uri="{FF2B5EF4-FFF2-40B4-BE49-F238E27FC236}">
+                <a16:creationId xmlns:a16="http://schemas.microsoft.com/office/drawing/2014/main" id="{2217562E-AFA5-46A9-BB4D-BBC4457831D7}"/>
+              </a:ext>
+            </a:extLst>
+          </p:cNvPr>
+          <p:cNvCxnSpPr>
+            <a:cxnSpLocks/>
+            <a:endCxn id="5" idx="4"/>
+          </p:cNvCxnSpPr>
+          <p:nvPr/>
+        </p:nvCxnSpPr>
+        <p:spPr>
+          <a:xfrm flipH="1" flipV="1">
+            <a:off x="4651109" y="2887130"/>
+            <a:ext cx="1834455" cy="1825079"/>
+          </a:xfrm>
+          <a:prstGeom prst="straightConnector1">
+            <a:avLst/>
+          </a:prstGeom>
+          <a:ln w="25400">
+            <a:solidFill>
+              <a:srgbClr val="FF0000"/>
+            </a:solidFill>
+            <a:tailEnd type="triangle" w="lg" len="lg"/>
+          </a:ln>
+        </p:spPr>
+        <p:style>
+          <a:lnRef idx="2">
+            <a:schemeClr val="accent1"/>
+          </a:lnRef>
+          <a:fillRef idx="0">
+            <a:schemeClr val="accent1"/>
+          </a:fillRef>
+          <a:effectRef idx="1">
+            <a:schemeClr val="accent1"/>
+          </a:effectRef>
+          <a:fontRef idx="minor">
+            <a:schemeClr val="tx1"/>
+          </a:fontRef>
+        </p:style>
+      </p:cxnSp>
+      <p:cxnSp>
+        <p:nvCxnSpPr>
+          <p:cNvPr id="19" name="Straight Arrow Connector 18">
+            <a:extLst>
+              <a:ext uri="{FF2B5EF4-FFF2-40B4-BE49-F238E27FC236}">
+                <a16:creationId xmlns:a16="http://schemas.microsoft.com/office/drawing/2014/main" id="{8BC18BEF-84F4-DBFC-9C45-6EB0191BEAAF}"/>
+              </a:ext>
+            </a:extLst>
+          </p:cNvPr>
+          <p:cNvCxnSpPr>
+            <a:cxnSpLocks/>
+            <a:endCxn id="6" idx="5"/>
+          </p:cNvCxnSpPr>
+          <p:nvPr/>
+        </p:nvCxnSpPr>
+        <p:spPr>
+          <a:xfrm flipH="1" flipV="1">
+            <a:off x="3825856" y="3377965"/>
+            <a:ext cx="2657074" cy="1330326"/>
+          </a:xfrm>
+          <a:prstGeom prst="straightConnector1">
+            <a:avLst/>
+          </a:prstGeom>
+          <a:ln w="25400">
+            <a:solidFill>
+              <a:srgbClr val="FF0000"/>
+            </a:solidFill>
+            <a:tailEnd type="triangle" w="lg" len="lg"/>
+          </a:ln>
+        </p:spPr>
+        <p:style>
+          <a:lnRef idx="2">
+            <a:schemeClr val="accent1"/>
+          </a:lnRef>
+          <a:fillRef idx="0">
+            <a:schemeClr val="accent1"/>
+          </a:fillRef>
+          <a:effectRef idx="1">
+            <a:schemeClr val="accent1"/>
+          </a:effectRef>
+          <a:fontRef idx="minor">
+            <a:schemeClr val="tx1"/>
+          </a:fontRef>
+        </p:style>
+      </p:cxnSp>
+      <p:cxnSp>
+        <p:nvCxnSpPr>
+          <p:cNvPr id="22" name="Straight Arrow Connector 21">
+            <a:extLst>
+              <a:ext uri="{FF2B5EF4-FFF2-40B4-BE49-F238E27FC236}">
+                <a16:creationId xmlns:a16="http://schemas.microsoft.com/office/drawing/2014/main" id="{591512B6-C2C9-0917-B62F-17586D9DD119}"/>
+              </a:ext>
+            </a:extLst>
+          </p:cNvPr>
+          <p:cNvCxnSpPr>
+            <a:cxnSpLocks/>
+            <a:endCxn id="7" idx="4"/>
+          </p:cNvCxnSpPr>
+          <p:nvPr/>
+        </p:nvCxnSpPr>
+        <p:spPr>
+          <a:xfrm flipH="1" flipV="1">
+            <a:off x="5810272" y="3451616"/>
+            <a:ext cx="672658" cy="1256675"/>
+          </a:xfrm>
+          <a:prstGeom prst="straightConnector1">
+            <a:avLst/>
+          </a:prstGeom>
+          <a:ln w="25400">
+            <a:solidFill>
+              <a:srgbClr val="FF0000"/>
+            </a:solidFill>
+            <a:tailEnd type="triangle" w="lg" len="lg"/>
+          </a:ln>
+        </p:spPr>
+        <p:style>
+          <a:lnRef idx="2">
+            <a:schemeClr val="accent1"/>
+          </a:lnRef>
+          <a:fillRef idx="0">
+            <a:schemeClr val="accent1"/>
+          </a:fillRef>
+          <a:effectRef idx="1">
+            <a:schemeClr val="accent1"/>
+          </a:effectRef>
+          <a:fontRef idx="minor">
+            <a:schemeClr val="tx1"/>
+          </a:fontRef>
+        </p:style>
+      </p:cxnSp>
+    </p:spTree>
+    <p:extLst>
+      <p:ext uri="{BB962C8B-B14F-4D97-AF65-F5344CB8AC3E}">
+        <p14:creationId xmlns:p14="http://schemas.microsoft.com/office/powerpoint/2010/main" val="3487998338"/>
+      </p:ext>
+    </p:extLst>
+  </p:cSld>
+  <p:clrMapOvr>
+    <a:masterClrMapping/>
+  </p:clrMapOvr>
+  <p:timing>
+    <p:tnLst>
+      <p:par>
+        <p:cTn id="1" dur="indefinite" restart="never" nodeType="tmRoot">
+          <p:childTnLst>
+            <p:seq concurrent="1" nextAc="seek">
+              <p:cTn id="2" dur="indefinite" nodeType="mainSeq">
+                <p:childTnLst>
+                  <p:par>
+                    <p:cTn id="3" fill="hold">
+                      <p:stCondLst>
+                        <p:cond delay="indefinite"/>
+                      </p:stCondLst>
+                      <p:childTnLst>
+                        <p:par>
+                          <p:cTn id="4" fill="hold">
+                            <p:stCondLst>
+                              <p:cond delay="0"/>
+                            </p:stCondLst>
+                            <p:childTnLst>
+                              <p:par>
+                                <p:cTn id="5" presetID="42" presetClass="entr" presetSubtype="0" fill="hold" grpId="0" nodeType="clickEffect">
+                                  <p:stCondLst>
+                                    <p:cond delay="0"/>
+                                  </p:stCondLst>
+                                  <p:childTnLst>
+                                    <p:set>
+                                      <p:cBhvr>
+                                        <p:cTn id="6" dur="1" fill="hold">
+                                          <p:stCondLst>
+                                            <p:cond delay="0"/>
+                                          </p:stCondLst>
+                                        </p:cTn>
+                                        <p:tgtEl>
+                                          <p:spTgt spid="9"/>
+                                        </p:tgtEl>
+                                        <p:attrNameLst>
+                                          <p:attrName>style.visibility</p:attrName>
+                                        </p:attrNameLst>
+                                      </p:cBhvr>
+                                      <p:to>
+                                        <p:strVal val="visible"/>
+                                      </p:to>
+                                    </p:set>
+                                    <p:animEffect transition="in" filter="fade">
+                                      <p:cBhvr>
+                                        <p:cTn id="7" dur="1000"/>
+                                        <p:tgtEl>
+                                          <p:spTgt spid="9"/>
+                                        </p:tgtEl>
+                                      </p:cBhvr>
+                                    </p:animEffect>
+                                    <p:anim calcmode="lin" valueType="num">
+                                      <p:cBhvr>
+                                        <p:cTn id="8" dur="1000" fill="hold"/>
+                                        <p:tgtEl>
+                                          <p:spTgt spid="9"/>
+                                        </p:tgtEl>
+                                        <p:attrNameLst>
+                                          <p:attrName>ppt_x</p:attrName>
+                                        </p:attrNameLst>
+                                      </p:cBhvr>
+                                      <p:tavLst>
+                                        <p:tav tm="0">
+                                          <p:val>
+                                            <p:strVal val="#ppt_x"/>
+                                          </p:val>
+                                        </p:tav>
+                                        <p:tav tm="100000">
+                                          <p:val>
+                                            <p:strVal val="#ppt_x"/>
+                                          </p:val>
+                                        </p:tav>
+                                      </p:tavLst>
+                                    </p:anim>
+                                    <p:anim calcmode="lin" valueType="num">
+                                      <p:cBhvr>
+                                        <p:cTn id="9" dur="1000" fill="hold"/>
+                                        <p:tgtEl>
+                                          <p:spTgt spid="9"/>
+                                        </p:tgtEl>
+                                        <p:attrNameLst>
+                                          <p:attrName>ppt_y</p:attrName>
+                                        </p:attrNameLst>
+                                      </p:cBhvr>
+                                      <p:tavLst>
+                                        <p:tav tm="0">
+                                          <p:val>
+                                            <p:strVal val="#ppt_y+.1"/>
+                                          </p:val>
+                                        </p:tav>
+                                        <p:tav tm="100000">
+                                          <p:val>
+                                            <p:strVal val="#ppt_y"/>
+                                          </p:val>
+                                        </p:tav>
+                                      </p:tavLst>
+                                    </p:anim>
+                                  </p:childTnLst>
+                                </p:cTn>
+                              </p:par>
+                            </p:childTnLst>
+                          </p:cTn>
+                        </p:par>
+                        <p:par>
+                          <p:cTn id="10" fill="hold">
+                            <p:stCondLst>
+                              <p:cond delay="1000"/>
+                            </p:stCondLst>
+                            <p:childTnLst>
+                              <p:par>
+                                <p:cTn id="11" presetID="22" presetClass="entr" presetSubtype="2" fill="hold" nodeType="afterEffect">
+                                  <p:stCondLst>
+                                    <p:cond delay="0"/>
+                                  </p:stCondLst>
+                                  <p:childTnLst>
+                                    <p:set>
+                                      <p:cBhvr>
+                                        <p:cTn id="12" dur="1" fill="hold">
+                                          <p:stCondLst>
+                                            <p:cond delay="0"/>
+                                          </p:stCondLst>
+                                        </p:cTn>
+                                        <p:tgtEl>
+                                          <p:spTgt spid="15"/>
+                                        </p:tgtEl>
+                                        <p:attrNameLst>
+                                          <p:attrName>style.visibility</p:attrName>
+                                        </p:attrNameLst>
+                                      </p:cBhvr>
+                                      <p:to>
+                                        <p:strVal val="visible"/>
+                                      </p:to>
+                                    </p:set>
+                                    <p:animEffect transition="in" filter="wipe(right)">
+                                      <p:cBhvr>
+                                        <p:cTn id="13" dur="500"/>
+                                        <p:tgtEl>
+                                          <p:spTgt spid="15"/>
+                                        </p:tgtEl>
+                                      </p:cBhvr>
+                                    </p:animEffect>
+                                  </p:childTnLst>
+                                </p:cTn>
+                              </p:par>
+                            </p:childTnLst>
+                          </p:cTn>
+                        </p:par>
+                        <p:par>
+                          <p:cTn id="14" fill="hold">
+                            <p:stCondLst>
+                              <p:cond delay="1500"/>
+                            </p:stCondLst>
+                            <p:childTnLst>
+                              <p:par>
+                                <p:cTn id="15" presetID="21" presetClass="entr" presetSubtype="1" fill="hold" grpId="0" nodeType="afterEffect">
+                                  <p:stCondLst>
+                                    <p:cond delay="0"/>
+                                  </p:stCondLst>
+                                  <p:childTnLst>
+                                    <p:set>
+                                      <p:cBhvr>
+                                        <p:cTn id="16" dur="1" fill="hold">
+                                          <p:stCondLst>
+                                            <p:cond delay="0"/>
+                                          </p:stCondLst>
+                                        </p:cTn>
+                                        <p:tgtEl>
+                                          <p:spTgt spid="4"/>
+                                        </p:tgtEl>
+                                        <p:attrNameLst>
+                                          <p:attrName>style.visibility</p:attrName>
+                                        </p:attrNameLst>
+                                      </p:cBhvr>
+                                      <p:to>
+                                        <p:strVal val="visible"/>
+                                      </p:to>
+                                    </p:set>
+                                    <p:animEffect transition="in" filter="wheel(1)">
+                                      <p:cBhvr>
+                                        <p:cTn id="17" dur="500"/>
+                                        <p:tgtEl>
+                                          <p:spTgt spid="4"/>
+                                        </p:tgtEl>
+                                      </p:cBhvr>
+                                    </p:animEffect>
+                                  </p:childTnLst>
+                                </p:cTn>
+                              </p:par>
+                            </p:childTnLst>
+                          </p:cTn>
+                        </p:par>
+                        <p:par>
+                          <p:cTn id="18" fill="hold">
+                            <p:stCondLst>
+                              <p:cond delay="2000"/>
+                            </p:stCondLst>
+                            <p:childTnLst>
+                              <p:par>
+                                <p:cTn id="19" presetID="22" presetClass="entr" presetSubtype="2" fill="hold" nodeType="afterEffect">
+                                  <p:stCondLst>
+                                    <p:cond delay="0"/>
+                                  </p:stCondLst>
+                                  <p:childTnLst>
+                                    <p:set>
+                                      <p:cBhvr>
+                                        <p:cTn id="20" dur="1" fill="hold">
+                                          <p:stCondLst>
+                                            <p:cond delay="0"/>
+                                          </p:stCondLst>
+                                        </p:cTn>
+                                        <p:tgtEl>
+                                          <p:spTgt spid="16"/>
+                                        </p:tgtEl>
+                                        <p:attrNameLst>
+                                          <p:attrName>style.visibility</p:attrName>
+                                        </p:attrNameLst>
+                                      </p:cBhvr>
+                                      <p:to>
+                                        <p:strVal val="visible"/>
+                                      </p:to>
+                                    </p:set>
+                                    <p:animEffect transition="in" filter="wipe(right)">
+                                      <p:cBhvr>
+                                        <p:cTn id="21" dur="500"/>
+                                        <p:tgtEl>
+                                          <p:spTgt spid="16"/>
+                                        </p:tgtEl>
+                                      </p:cBhvr>
+                                    </p:animEffect>
+                                  </p:childTnLst>
+                                </p:cTn>
+                              </p:par>
+                            </p:childTnLst>
+                          </p:cTn>
+                        </p:par>
+                        <p:par>
+                          <p:cTn id="22" fill="hold">
+                            <p:stCondLst>
+                              <p:cond delay="2500"/>
+                            </p:stCondLst>
+                            <p:childTnLst>
+                              <p:par>
+                                <p:cTn id="23" presetID="21" presetClass="entr" presetSubtype="1" fill="hold" grpId="0" nodeType="afterEffect">
+                                  <p:stCondLst>
+                                    <p:cond delay="0"/>
+                                  </p:stCondLst>
+                                  <p:childTnLst>
+                                    <p:set>
+                                      <p:cBhvr>
+                                        <p:cTn id="24" dur="1" fill="hold">
+                                          <p:stCondLst>
+                                            <p:cond delay="0"/>
+                                          </p:stCondLst>
+                                        </p:cTn>
+                                        <p:tgtEl>
+                                          <p:spTgt spid="5"/>
+                                        </p:tgtEl>
+                                        <p:attrNameLst>
+                                          <p:attrName>style.visibility</p:attrName>
+                                        </p:attrNameLst>
+                                      </p:cBhvr>
+                                      <p:to>
+                                        <p:strVal val="visible"/>
+                                      </p:to>
+                                    </p:set>
+                                    <p:animEffect transition="in" filter="wheel(1)">
+                                      <p:cBhvr>
+                                        <p:cTn id="25" dur="500"/>
+                                        <p:tgtEl>
+                                          <p:spTgt spid="5"/>
+                                        </p:tgtEl>
+                                      </p:cBhvr>
+                                    </p:animEffect>
+                                  </p:childTnLst>
+                                </p:cTn>
+                              </p:par>
+                            </p:childTnLst>
+                          </p:cTn>
+                        </p:par>
+                        <p:par>
+                          <p:cTn id="26" fill="hold">
+                            <p:stCondLst>
+                              <p:cond delay="3000"/>
+                            </p:stCondLst>
+                            <p:childTnLst>
+                              <p:par>
+                                <p:cTn id="27" presetID="22" presetClass="entr" presetSubtype="2" fill="hold" nodeType="afterEffect">
+                                  <p:stCondLst>
+                                    <p:cond delay="0"/>
+                                  </p:stCondLst>
+                                  <p:childTnLst>
+                                    <p:set>
+                                      <p:cBhvr>
+                                        <p:cTn id="28" dur="1" fill="hold">
+                                          <p:stCondLst>
+                                            <p:cond delay="0"/>
+                                          </p:stCondLst>
+                                        </p:cTn>
+                                        <p:tgtEl>
+                                          <p:spTgt spid="19"/>
+                                        </p:tgtEl>
+                                        <p:attrNameLst>
+                                          <p:attrName>style.visibility</p:attrName>
+                                        </p:attrNameLst>
+                                      </p:cBhvr>
+                                      <p:to>
+                                        <p:strVal val="visible"/>
+                                      </p:to>
+                                    </p:set>
+                                    <p:animEffect transition="in" filter="wipe(right)">
+                                      <p:cBhvr>
+                                        <p:cTn id="29" dur="500"/>
+                                        <p:tgtEl>
+                                          <p:spTgt spid="19"/>
+                                        </p:tgtEl>
+                                      </p:cBhvr>
+                                    </p:animEffect>
+                                  </p:childTnLst>
+                                </p:cTn>
+                              </p:par>
+                            </p:childTnLst>
+                          </p:cTn>
+                        </p:par>
+                        <p:par>
+                          <p:cTn id="30" fill="hold">
+                            <p:stCondLst>
+                              <p:cond delay="3500"/>
+                            </p:stCondLst>
+                            <p:childTnLst>
+                              <p:par>
+                                <p:cTn id="31" presetID="21" presetClass="entr" presetSubtype="1" fill="hold" grpId="0" nodeType="afterEffect">
+                                  <p:stCondLst>
+                                    <p:cond delay="0"/>
+                                  </p:stCondLst>
+                                  <p:childTnLst>
+                                    <p:set>
+                                      <p:cBhvr>
+                                        <p:cTn id="32" dur="1" fill="hold">
+                                          <p:stCondLst>
+                                            <p:cond delay="0"/>
+                                          </p:stCondLst>
+                                        </p:cTn>
+                                        <p:tgtEl>
+                                          <p:spTgt spid="6"/>
+                                        </p:tgtEl>
+                                        <p:attrNameLst>
+                                          <p:attrName>style.visibility</p:attrName>
+                                        </p:attrNameLst>
+                                      </p:cBhvr>
+                                      <p:to>
+                                        <p:strVal val="visible"/>
+                                      </p:to>
+                                    </p:set>
+                                    <p:animEffect transition="in" filter="wheel(1)">
+                                      <p:cBhvr>
+                                        <p:cTn id="33" dur="500"/>
+                                        <p:tgtEl>
+                                          <p:spTgt spid="6"/>
+                                        </p:tgtEl>
+                                      </p:cBhvr>
+                                    </p:animEffect>
+                                  </p:childTnLst>
+                                </p:cTn>
+                              </p:par>
+                            </p:childTnLst>
+                          </p:cTn>
+                        </p:par>
+                        <p:par>
+                          <p:cTn id="34" fill="hold">
+                            <p:stCondLst>
+                              <p:cond delay="4000"/>
+                            </p:stCondLst>
+                            <p:childTnLst>
+                              <p:par>
+                                <p:cTn id="35" presetID="22" presetClass="entr" presetSubtype="2" fill="hold" nodeType="afterEffect">
+                                  <p:stCondLst>
+                                    <p:cond delay="0"/>
+                                  </p:stCondLst>
+                                  <p:childTnLst>
+                                    <p:set>
+                                      <p:cBhvr>
+                                        <p:cTn id="36" dur="1" fill="hold">
+                                          <p:stCondLst>
+                                            <p:cond delay="0"/>
+                                          </p:stCondLst>
+                                        </p:cTn>
+                                        <p:tgtEl>
+                                          <p:spTgt spid="22"/>
+                                        </p:tgtEl>
+                                        <p:attrNameLst>
+                                          <p:attrName>style.visibility</p:attrName>
+                                        </p:attrNameLst>
+                                      </p:cBhvr>
+                                      <p:to>
+                                        <p:strVal val="visible"/>
+                                      </p:to>
+                                    </p:set>
+                                    <p:animEffect transition="in" filter="wipe(right)">
+                                      <p:cBhvr>
+                                        <p:cTn id="37" dur="500"/>
+                                        <p:tgtEl>
+                                          <p:spTgt spid="22"/>
+                                        </p:tgtEl>
+                                      </p:cBhvr>
+                                    </p:animEffect>
+                                  </p:childTnLst>
+                                </p:cTn>
+                              </p:par>
+                            </p:childTnLst>
+                          </p:cTn>
+                        </p:par>
+                        <p:par>
+                          <p:cTn id="38" fill="hold">
+                            <p:stCondLst>
+                              <p:cond delay="4500"/>
+                            </p:stCondLst>
+                            <p:childTnLst>
+                              <p:par>
+                                <p:cTn id="39" presetID="21" presetClass="entr" presetSubtype="1" fill="hold" grpId="0" nodeType="afterEffect">
+                                  <p:stCondLst>
+                                    <p:cond delay="0"/>
+                                  </p:stCondLst>
+                                  <p:childTnLst>
+                                    <p:set>
+                                      <p:cBhvr>
+                                        <p:cTn id="40" dur="1" fill="hold">
+                                          <p:stCondLst>
+                                            <p:cond delay="0"/>
+                                          </p:stCondLst>
+                                        </p:cTn>
+                                        <p:tgtEl>
+                                          <p:spTgt spid="7"/>
+                                        </p:tgtEl>
+                                        <p:attrNameLst>
+                                          <p:attrName>style.visibility</p:attrName>
+                                        </p:attrNameLst>
+                                      </p:cBhvr>
+                                      <p:to>
+                                        <p:strVal val="visible"/>
+                                      </p:to>
+                                    </p:set>
+                                    <p:animEffect transition="in" filter="wheel(1)">
+                                      <p:cBhvr>
+                                        <p:cTn id="41" dur="500"/>
+                                        <p:tgtEl>
+                                          <p:spTgt spid="7"/>
+                                        </p:tgtEl>
+                                      </p:cBhvr>
+                                    </p:animEffect>
+                                  </p:childTnLst>
+                                </p:cTn>
+                              </p:par>
+                            </p:childTnLst>
+                          </p:cTn>
+                        </p:par>
+                      </p:childTnLst>
+                    </p:cTn>
+                  </p:par>
+                  <p:par>
+                    <p:cTn id="42" fill="hold">
+                      <p:stCondLst>
+                        <p:cond delay="indefinite"/>
+                      </p:stCondLst>
+                      <p:childTnLst>
+                        <p:par>
+                          <p:cTn id="43" fill="hold">
+                            <p:stCondLst>
+                              <p:cond delay="0"/>
+                            </p:stCondLst>
+                            <p:childTnLst>
+                              <p:par>
+                                <p:cTn id="44" presetID="42" presetClass="entr" presetSubtype="0" fill="hold" grpId="0" nodeType="clickEffect">
+                                  <p:stCondLst>
+                                    <p:cond delay="0"/>
+                                  </p:stCondLst>
+                                  <p:childTnLst>
+                                    <p:set>
+                                      <p:cBhvr>
+                                        <p:cTn id="45" dur="1" fill="hold">
+                                          <p:stCondLst>
+                                            <p:cond delay="0"/>
+                                          </p:stCondLst>
+                                        </p:cTn>
+                                        <p:tgtEl>
+                                          <p:spTgt spid="10"/>
+                                        </p:tgtEl>
+                                        <p:attrNameLst>
+                                          <p:attrName>style.visibility</p:attrName>
+                                        </p:attrNameLst>
+                                      </p:cBhvr>
+                                      <p:to>
+                                        <p:strVal val="visible"/>
+                                      </p:to>
+                                    </p:set>
+                                    <p:animEffect transition="in" filter="fade">
+                                      <p:cBhvr>
+                                        <p:cTn id="46" dur="1000"/>
+                                        <p:tgtEl>
+                                          <p:spTgt spid="10"/>
+                                        </p:tgtEl>
+                                      </p:cBhvr>
+                                    </p:animEffect>
+                                    <p:anim calcmode="lin" valueType="num">
+                                      <p:cBhvr>
+                                        <p:cTn id="47" dur="1000" fill="hold"/>
+                                        <p:tgtEl>
+                                          <p:spTgt spid="10"/>
+                                        </p:tgtEl>
+                                        <p:attrNameLst>
+                                          <p:attrName>ppt_x</p:attrName>
+                                        </p:attrNameLst>
+                                      </p:cBhvr>
+                                      <p:tavLst>
+                                        <p:tav tm="0">
+                                          <p:val>
+                                            <p:strVal val="#ppt_x"/>
+                                          </p:val>
+                                        </p:tav>
+                                        <p:tav tm="100000">
+                                          <p:val>
+                                            <p:strVal val="#ppt_x"/>
+                                          </p:val>
+                                        </p:tav>
+                                      </p:tavLst>
+                                    </p:anim>
+                                    <p:anim calcmode="lin" valueType="num">
+                                      <p:cBhvr>
+                                        <p:cTn id="48" dur="1000" fill="hold"/>
+                                        <p:tgtEl>
+                                          <p:spTgt spid="10"/>
+                                        </p:tgtEl>
+                                        <p:attrNameLst>
+                                          <p:attrName>ppt_y</p:attrName>
+                                        </p:attrNameLst>
+                                      </p:cBhvr>
+                                      <p:tavLst>
+                                        <p:tav tm="0">
+                                          <p:val>
+                                            <p:strVal val="#ppt_y+.1"/>
+                                          </p:val>
+                                        </p:tav>
+                                        <p:tav tm="100000">
+                                          <p:val>
+                                            <p:strVal val="#ppt_y"/>
+                                          </p:val>
+                                        </p:tav>
+                                      </p:tavLst>
+                                    </p:anim>
+                                  </p:childTnLst>
+                                </p:cTn>
+                              </p:par>
+                            </p:childTnLst>
+                          </p:cTn>
+                        </p:par>
+                      </p:childTnLst>
+                    </p:cTn>
+                  </p:par>
+                </p:childTnLst>
+              </p:cTn>
+              <p:prevCondLst>
+                <p:cond evt="onPrev" delay="0">
+                  <p:tgtEl>
+                    <p:sldTgt/>
+                  </p:tgtEl>
+                </p:cond>
+              </p:prevCondLst>
+              <p:nextCondLst>
+                <p:cond evt="onNext" delay="0">
+                  <p:tgtEl>
+                    <p:sldTgt/>
+                  </p:tgtEl>
+                </p:cond>
+              </p:nextCondLst>
+            </p:seq>
+          </p:childTnLst>
+        </p:cTn>
+      </p:par>
+    </p:tnLst>
+    <p:bldLst>
+      <p:bldP spid="4" grpId="0" animBg="1"/>
+      <p:bldP spid="5" grpId="0" animBg="1"/>
+      <p:bldP spid="6" grpId="0" animBg="1"/>
+      <p:bldP spid="7" grpId="0" animBg="1"/>
+      <p:bldP spid="9" grpId="0"/>
+      <p:bldP spid="10" grpId="0"/>
+    </p:bldLst>
+  </p:timing>
+</p:sld>
+</file>
+
+<file path=ppt/slides/slide4.xml><?xml version="1.0" encoding="utf-8"?>
+<p:sld xmlns:a="http://schemas.openxmlformats.org/drawingml/2006/main" xmlns:r="http://schemas.openxmlformats.org/officeDocument/2006/relationships" xmlns:p="http://schemas.openxmlformats.org/presentationml/2006/main">
+  <p:cSld>
+    <p:spTree>
+      <p:nvGrpSpPr>
+        <p:cNvPr id="1" name="">
+          <a:extLst>
+            <a:ext uri="{FF2B5EF4-FFF2-40B4-BE49-F238E27FC236}">
+              <a16:creationId xmlns:a16="http://schemas.microsoft.com/office/drawing/2014/main" id="{0AED29C6-DEF8-0C9C-5878-6B81FC79045C}"/>
+            </a:ext>
+          </a:extLst>
+        </p:cNvPr>
+        <p:cNvGrpSpPr/>
+        <p:nvPr/>
+      </p:nvGrpSpPr>
+      <p:grpSpPr>
+        <a:xfrm>
+          <a:off x="0" y="0"/>
+          <a:ext cx="0" cy="0"/>
+          <a:chOff x="0" y="0"/>
+          <a:chExt cx="0" cy="0"/>
+        </a:xfrm>
+      </p:grpSpPr>
+      <mc:AlternateContent xmlns:mc="http://schemas.openxmlformats.org/markup-compatibility/2006">
+        <mc:Choice xmlns:a14="http://schemas.microsoft.com/office/drawing/2010/main" Requires="a14">
+          <p:sp>
+            <p:nvSpPr>
+              <p:cNvPr id="3" name="Content Placeholder 2">
+                <a:extLst>
+                  <a:ext uri="{FF2B5EF4-FFF2-40B4-BE49-F238E27FC236}">
+                    <a16:creationId xmlns:a16="http://schemas.microsoft.com/office/drawing/2014/main" id="{508FA53A-081E-A0C9-2591-B7787F5C3B69}"/>
+                  </a:ext>
+                </a:extLst>
+              </p:cNvPr>
+              <p:cNvSpPr>
+                <a:spLocks noGrp="1"/>
+              </p:cNvSpPr>
+              <p:nvPr>
+                <p:ph idx="1"/>
+              </p:nvPr>
+            </p:nvSpPr>
+            <p:spPr>
+              <a:xfrm>
+                <a:off x="441036" y="1262207"/>
+                <a:ext cx="6001882" cy="4351338"/>
+              </a:xfrm>
+            </p:spPr>
+            <p:txBody>
+              <a:bodyPr/>
+              <a:lstStyle/>
+              <a:p>
+                <a:pPr marL="0" indent="0">
+                  <a:buNone/>
+                </a:pPr>
+                <a14:m>
+                  <m:oMathPara xmlns:m="http://schemas.openxmlformats.org/officeDocument/2006/math">
+                    <m:oMathParaPr>
+                      <m:jc m:val="centerGroup"/>
+                    </m:oMathParaPr>
+                    <m:oMath xmlns:m="http://schemas.openxmlformats.org/officeDocument/2006/math">
+                      <m:acc>
+                        <m:accPr>
+                          <m:chr m:val="̇"/>
+                          <m:ctrlPr>
+                            <a:rPr lang="en-US" i="1" smtClean="0">
+                              <a:latin typeface="Cambria Math" panose="02040503050406030204" pitchFamily="18" charset="0"/>
+                            </a:rPr>
+                          </m:ctrlPr>
+                        </m:accPr>
+                        <m:e>
+                          <m:r>
+                            <a:rPr lang="en-US" i="1" smtClean="0">
+                              <a:latin typeface="Cambria Math" panose="02040503050406030204" pitchFamily="18" charset="0"/>
+                              <a:ea typeface="Cambria Math" panose="02040503050406030204" pitchFamily="18" charset="0"/>
+                            </a:rPr>
+                            <m:t>𝜃</m:t>
+                          </m:r>
+                        </m:e>
+                      </m:acc>
+                      <m:r>
+                        <a:rPr lang="en-US" b="0" i="1" smtClean="0">
+                          <a:latin typeface="Cambria Math" panose="02040503050406030204" pitchFamily="18" charset="0"/>
+                        </a:rPr>
+                        <m:t>=</m:t>
+                      </m:r>
+                      <m:r>
+                        <a:rPr lang="en-US" b="0" i="1" smtClean="0">
+                          <a:latin typeface="Cambria Math" panose="02040503050406030204" pitchFamily="18" charset="0"/>
+                        </a:rPr>
+                        <m:t>𝑞</m:t>
+                      </m:r>
+                      <m:func>
+                        <m:funcPr>
+                          <m:ctrlPr>
+                            <a:rPr lang="en-US" b="0" i="1" smtClean="0">
+                              <a:latin typeface="Cambria Math" panose="02040503050406030204" pitchFamily="18" charset="0"/>
+                            </a:rPr>
+                          </m:ctrlPr>
+                        </m:funcPr>
+                        <m:fName>
+                          <m:r>
+                            <m:rPr>
+                              <m:sty m:val="p"/>
+                            </m:rPr>
+                            <a:rPr lang="en-US" b="0" i="0" smtClean="0">
+                              <a:latin typeface="Cambria Math" panose="02040503050406030204" pitchFamily="18" charset="0"/>
+                            </a:rPr>
+                            <m:t>cos</m:t>
+                          </m:r>
+                        </m:fName>
+                        <m:e>
+                          <m:r>
+                            <a:rPr lang="en-US" b="0" i="1" smtClean="0">
+                              <a:latin typeface="Cambria Math" panose="02040503050406030204" pitchFamily="18" charset="0"/>
+                              <a:ea typeface="Cambria Math" panose="02040503050406030204" pitchFamily="18" charset="0"/>
+                            </a:rPr>
+                            <m:t>𝜙</m:t>
+                          </m:r>
+                        </m:e>
+                      </m:func>
+                      <m:r>
+                        <a:rPr lang="en-US" b="0" i="1" smtClean="0">
+                          <a:latin typeface="Cambria Math" panose="02040503050406030204" pitchFamily="18" charset="0"/>
+                        </a:rPr>
+                        <m:t>−</m:t>
+                      </m:r>
+                      <m:r>
+                        <a:rPr lang="en-US" b="0" i="1" smtClean="0">
+                          <a:latin typeface="Cambria Math" panose="02040503050406030204" pitchFamily="18" charset="0"/>
+                        </a:rPr>
+                        <m:t>𝑟</m:t>
+                      </m:r>
+                      <m:func>
+                        <m:funcPr>
+                          <m:ctrlPr>
+                            <a:rPr lang="en-US" b="0" i="1" smtClean="0">
+                              <a:latin typeface="Cambria Math" panose="02040503050406030204" pitchFamily="18" charset="0"/>
+                            </a:rPr>
+                          </m:ctrlPr>
+                        </m:funcPr>
+                        <m:fName>
+                          <m:r>
+                            <m:rPr>
+                              <m:sty m:val="p"/>
+                            </m:rPr>
+                            <a:rPr lang="en-US" b="0" i="0" smtClean="0">
+                              <a:latin typeface="Cambria Math" panose="02040503050406030204" pitchFamily="18" charset="0"/>
+                            </a:rPr>
+                            <m:t>sin</m:t>
+                          </m:r>
+                        </m:fName>
+                        <m:e>
+                          <m:r>
+                            <a:rPr lang="en-US" b="0" i="1" smtClean="0">
+                              <a:latin typeface="Cambria Math" panose="02040503050406030204" pitchFamily="18" charset="0"/>
+                              <a:ea typeface="Cambria Math" panose="02040503050406030204" pitchFamily="18" charset="0"/>
+                            </a:rPr>
+                            <m:t>𝜙</m:t>
+                          </m:r>
+                        </m:e>
+                      </m:func>
+                    </m:oMath>
+                  </m:oMathPara>
+                </a14:m>
+                <a:endParaRPr lang="en-US" b="0" dirty="0"/>
+              </a:p>
+              <a:p>
+                <a:pPr marL="0" indent="0">
+                  <a:buNone/>
+                </a:pPr>
+                <a:endParaRPr lang="en-US" sz="1200" b="0" dirty="0"/>
+              </a:p>
+              <a:p>
+                <a:pPr marL="0" indent="0">
+                  <a:buNone/>
+                </a:pPr>
+                <a14:m>
+                  <m:oMathPara xmlns:m="http://schemas.openxmlformats.org/officeDocument/2006/math">
+                    <m:oMathParaPr>
+                      <m:jc m:val="centerGroup"/>
+                    </m:oMathParaPr>
+                    <m:oMath xmlns:m="http://schemas.openxmlformats.org/officeDocument/2006/math">
+                      <m:acc>
+                        <m:accPr>
+                          <m:chr m:val="̇"/>
+                          <m:ctrlPr>
+                            <a:rPr lang="en-US" i="1" smtClean="0">
+                              <a:latin typeface="Cambria Math" panose="02040503050406030204" pitchFamily="18" charset="0"/>
+                            </a:rPr>
+                          </m:ctrlPr>
+                        </m:accPr>
+                        <m:e>
+                          <m:r>
+                            <a:rPr lang="en-US" i="1" smtClean="0">
+                              <a:latin typeface="Cambria Math" panose="02040503050406030204" pitchFamily="18" charset="0"/>
+                              <a:ea typeface="Cambria Math" panose="02040503050406030204" pitchFamily="18" charset="0"/>
+                            </a:rPr>
+                            <m:t>𝜓</m:t>
+                          </m:r>
+                        </m:e>
+                      </m:acc>
+                      <m:r>
+                        <a:rPr lang="en-US" b="0" i="1" smtClean="0">
+                          <a:latin typeface="Cambria Math" panose="02040503050406030204" pitchFamily="18" charset="0"/>
+                        </a:rPr>
+                        <m:t>=</m:t>
+                      </m:r>
+                      <m:r>
+                        <a:rPr lang="en-US" b="0" i="1" smtClean="0">
+                          <a:latin typeface="Cambria Math" panose="02040503050406030204" pitchFamily="18" charset="0"/>
+                        </a:rPr>
+                        <m:t>0</m:t>
+                      </m:r>
+                    </m:oMath>
+                  </m:oMathPara>
+                </a14:m>
+                <a:endParaRPr lang="en-US" dirty="0"/>
+              </a:p>
+              <a:p>
+                <a:pPr marL="0" indent="0">
+                  <a:buNone/>
+                </a:pPr>
+                <a:endParaRPr lang="en-US" sz="1200" dirty="0"/>
+              </a:p>
+              <a:p>
+                <a:pPr marL="0" indent="0">
+                  <a:buNone/>
+                </a:pPr>
+                <a14:m>
+                  <m:oMathPara xmlns:m="http://schemas.openxmlformats.org/officeDocument/2006/math">
+                    <m:oMathParaPr>
+                      <m:jc m:val="centerGroup"/>
+                    </m:oMathParaPr>
+                    <m:oMath xmlns:m="http://schemas.openxmlformats.org/officeDocument/2006/math">
+                      <m:acc>
+                        <m:accPr>
+                          <m:chr m:val="̇"/>
+                          <m:ctrlPr>
+                            <a:rPr lang="en-US" i="1" smtClean="0">
+                              <a:latin typeface="Cambria Math" panose="02040503050406030204" pitchFamily="18" charset="0"/>
+                            </a:rPr>
+                          </m:ctrlPr>
+                        </m:accPr>
+                        <m:e>
+                          <m:r>
+                            <a:rPr lang="en-US" i="1" smtClean="0">
+                              <a:latin typeface="Cambria Math" panose="02040503050406030204" pitchFamily="18" charset="0"/>
+                              <a:ea typeface="Cambria Math" panose="02040503050406030204" pitchFamily="18" charset="0"/>
+                            </a:rPr>
+                            <m:t>𝜙</m:t>
+                          </m:r>
+                        </m:e>
+                      </m:acc>
+                      <m:r>
+                        <a:rPr lang="en-US" b="0" i="1" smtClean="0">
+                          <a:latin typeface="Cambria Math" panose="02040503050406030204" pitchFamily="18" charset="0"/>
+                        </a:rPr>
+                        <m:t>=</m:t>
+                      </m:r>
+                      <m:r>
+                        <a:rPr lang="en-US" b="0" i="1" smtClean="0">
+                          <a:latin typeface="Cambria Math" panose="02040503050406030204" pitchFamily="18" charset="0"/>
+                        </a:rPr>
+                        <m:t>𝑝</m:t>
+                      </m:r>
+                      <m:r>
+                        <a:rPr lang="en-US" b="0" i="1" smtClean="0">
+                          <a:latin typeface="Cambria Math" panose="02040503050406030204" pitchFamily="18" charset="0"/>
+                        </a:rPr>
+                        <m:t>+</m:t>
+                      </m:r>
+                      <m:r>
+                        <a:rPr lang="en-US" b="0" i="1" smtClean="0">
+                          <a:latin typeface="Cambria Math" panose="02040503050406030204" pitchFamily="18" charset="0"/>
+                        </a:rPr>
+                        <m:t>𝑟</m:t>
+                      </m:r>
+                    </m:oMath>
+                  </m:oMathPara>
+                </a14:m>
+                <a:endParaRPr lang="en-US" dirty="0"/>
+              </a:p>
+            </p:txBody>
+          </p:sp>
+        </mc:Choice>
+        <mc:Fallback>
+          <p:sp>
+            <p:nvSpPr>
+              <p:cNvPr id="3" name="Content Placeholder 2">
+                <a:extLst>
+                  <a:ext uri="{FF2B5EF4-FFF2-40B4-BE49-F238E27FC236}">
+                    <a16:creationId xmlns:a16="http://schemas.microsoft.com/office/drawing/2014/main" id="{508FA53A-081E-A0C9-2591-B7787F5C3B69}"/>
+                  </a:ext>
+                </a:extLst>
+              </p:cNvPr>
+              <p:cNvSpPr>
+                <a:spLocks noGrp="1" noRot="1" noChangeAspect="1" noMove="1" noResize="1" noEditPoints="1" noAdjustHandles="1" noChangeArrowheads="1" noChangeShapeType="1" noTextEdit="1"/>
+              </p:cNvSpPr>
+              <p:nvPr>
+                <p:ph idx="1"/>
+              </p:nvPr>
+            </p:nvSpPr>
+            <p:spPr>
+              <a:xfrm>
+                <a:off x="441036" y="1262207"/>
+                <a:ext cx="6001882" cy="4351338"/>
+              </a:xfrm>
+              <a:blipFill>
+                <a:blip r:embed="rId2"/>
+                <a:stretch>
+                  <a:fillRect t="-1541"/>
+                </a:stretch>
+              </a:blipFill>
+            </p:spPr>
+            <p:txBody>
+              <a:bodyPr/>
+              <a:lstStyle/>
+              <a:p>
+                <a:r>
+                  <a:rPr lang="en-US">
+                    <a:noFill/>
+                  </a:rPr>
+                  <a:t> </a:t>
+                </a:r>
+              </a:p>
+            </p:txBody>
+          </p:sp>
+        </mc:Fallback>
+      </mc:AlternateContent>
+      <mc:AlternateContent xmlns:mc="http://schemas.openxmlformats.org/markup-compatibility/2006">
+        <mc:Choice xmlns:a14="http://schemas.microsoft.com/office/drawing/2010/main" Requires="a14">
+          <p:sp>
+            <p:nvSpPr>
+              <p:cNvPr id="8" name="TextBox 7">
+                <a:extLst>
+                  <a:ext uri="{FF2B5EF4-FFF2-40B4-BE49-F238E27FC236}">
+                    <a16:creationId xmlns:a16="http://schemas.microsoft.com/office/drawing/2014/main" id="{5D2BED82-259D-A054-9688-F10B85B7612E}"/>
+                  </a:ext>
+                </a:extLst>
+              </p:cNvPr>
+              <p:cNvSpPr txBox="1"/>
+              <p:nvPr/>
+            </p:nvSpPr>
+            <p:spPr>
+              <a:xfrm>
+                <a:off x="8238836" y="440171"/>
+                <a:ext cx="3389746" cy="2031325"/>
+              </a:xfrm>
+              <a:prstGeom prst="rect">
+                <a:avLst/>
+              </a:prstGeom>
+              <a:noFill/>
+            </p:spPr>
+            <p:txBody>
+              <a:bodyPr wrap="square" rtlCol="0">
+                <a:spAutoFit/>
+              </a:bodyPr>
+              <a:lstStyle/>
+              <a:p>
+                <a14:m>
+                  <m:oMath xmlns:m="http://schemas.openxmlformats.org/officeDocument/2006/math">
+                    <m:r>
+                      <a:rPr lang="en-US" i="1">
+                        <a:latin typeface="Cambria Math" panose="02040503050406030204" pitchFamily="18" charset="0"/>
+                        <a:ea typeface="Cambria Math" panose="02040503050406030204" pitchFamily="18" charset="0"/>
+                      </a:rPr>
+                      <m:t>𝜙</m:t>
+                    </m:r>
+                  </m:oMath>
+                </a14:m>
+                <a:r>
+                  <a:rPr lang="en-US" dirty="0"/>
+                  <a:t>  roll</a:t>
+                </a:r>
+              </a:p>
+              <a:p>
+                <a14:m>
+                  <m:oMath xmlns:m="http://schemas.openxmlformats.org/officeDocument/2006/math">
+                    <m:r>
+                      <a:rPr lang="en-US" i="1" smtClean="0">
+                        <a:latin typeface="Cambria Math" panose="02040503050406030204" pitchFamily="18" charset="0"/>
+                        <a:ea typeface="Cambria Math" panose="02040503050406030204" pitchFamily="18" charset="0"/>
+                      </a:rPr>
+                      <m:t>𝜃</m:t>
+                    </m:r>
+                  </m:oMath>
+                </a14:m>
+                <a:r>
+                  <a:rPr lang="en-US" dirty="0">
+                    <a:ea typeface="Cambria Math" panose="02040503050406030204" pitchFamily="18" charset="0"/>
+                  </a:rPr>
+                  <a:t>  pitch</a:t>
+                </a:r>
+              </a:p>
+              <a:p>
+                <a14:m>
+                  <m:oMath xmlns:m="http://schemas.openxmlformats.org/officeDocument/2006/math">
+                    <m:r>
+                      <a:rPr lang="en-US" i="1">
+                        <a:latin typeface="Cambria Math" panose="02040503050406030204" pitchFamily="18" charset="0"/>
+                        <a:ea typeface="Cambria Math" panose="02040503050406030204" pitchFamily="18" charset="0"/>
+                      </a:rPr>
+                      <m:t>𝜓</m:t>
+                    </m:r>
+                  </m:oMath>
+                </a14:m>
+                <a:r>
+                  <a:rPr lang="en-US" dirty="0">
+                    <a:ea typeface="Cambria Math" panose="02040503050406030204" pitchFamily="18" charset="0"/>
+                  </a:rPr>
+                  <a:t>  yaw</a:t>
+                </a:r>
+              </a:p>
+              <a:p>
+                <a:endParaRPr lang="en-US" dirty="0"/>
+              </a:p>
+              <a:p>
+                <a14:m>
+                  <m:oMath xmlns:m="http://schemas.openxmlformats.org/officeDocument/2006/math">
+                    <m:r>
+                      <a:rPr lang="en-US" b="0" i="1" smtClean="0">
+                        <a:latin typeface="Cambria Math" panose="02040503050406030204" pitchFamily="18" charset="0"/>
+                      </a:rPr>
+                      <m:t>𝑝</m:t>
+                    </m:r>
+                  </m:oMath>
+                </a14:m>
+                <a:r>
+                  <a:rPr lang="en-US" b="0" dirty="0"/>
+                  <a:t>  body axis roll rate</a:t>
+                </a:r>
+              </a:p>
+              <a:p>
+                <a14:m>
+                  <m:oMath xmlns:m="http://schemas.openxmlformats.org/officeDocument/2006/math">
+                    <m:r>
+                      <a:rPr lang="en-US" b="0" i="1" smtClean="0">
+                        <a:latin typeface="Cambria Math" panose="02040503050406030204" pitchFamily="18" charset="0"/>
+                      </a:rPr>
+                      <m:t>𝑞</m:t>
+                    </m:r>
+                  </m:oMath>
+                </a14:m>
+                <a:r>
+                  <a:rPr lang="en-US" b="0" dirty="0"/>
+                  <a:t>  body axis pitch rate</a:t>
+                </a:r>
+              </a:p>
+              <a:p>
+                <a14:m>
+                  <m:oMath xmlns:m="http://schemas.openxmlformats.org/officeDocument/2006/math">
+                    <m:r>
+                      <a:rPr lang="en-US" b="0" i="1" smtClean="0">
+                        <a:latin typeface="Cambria Math" panose="02040503050406030204" pitchFamily="18" charset="0"/>
+                      </a:rPr>
+                      <m:t>𝑟</m:t>
+                    </m:r>
+                  </m:oMath>
+                </a14:m>
+                <a:r>
+                  <a:rPr lang="en-US" dirty="0"/>
+                  <a:t>  body axis yaw rate</a:t>
+                </a:r>
+              </a:p>
+            </p:txBody>
+          </p:sp>
+        </mc:Choice>
+        <mc:Fallback>
+          <p:sp>
+            <p:nvSpPr>
+              <p:cNvPr id="8" name="TextBox 7">
+                <a:extLst>
+                  <a:ext uri="{FF2B5EF4-FFF2-40B4-BE49-F238E27FC236}">
+                    <a16:creationId xmlns:a16="http://schemas.microsoft.com/office/drawing/2014/main" id="{5D2BED82-259D-A054-9688-F10B85B7612E}"/>
+                  </a:ext>
+                </a:extLst>
+              </p:cNvPr>
+              <p:cNvSpPr txBox="1">
+                <a:spLocks noRot="1" noChangeAspect="1" noMove="1" noResize="1" noEditPoints="1" noAdjustHandles="1" noChangeArrowheads="1" noChangeShapeType="1" noTextEdit="1"/>
+              </p:cNvSpPr>
+              <p:nvPr/>
+            </p:nvSpPr>
+            <p:spPr>
+              <a:xfrm>
+                <a:off x="8238836" y="440171"/>
+                <a:ext cx="3389746" cy="2031325"/>
+              </a:xfrm>
+              <a:prstGeom prst="rect">
+                <a:avLst/>
+              </a:prstGeom>
+              <a:blipFill>
+                <a:blip r:embed="rId3"/>
+                <a:stretch>
+                  <a:fillRect l="-540" t="-1201" b="-4204"/>
+                </a:stretch>
+              </a:blipFill>
+            </p:spPr>
+            <p:txBody>
+              <a:bodyPr/>
+              <a:lstStyle/>
+              <a:p>
+                <a:r>
+                  <a:rPr lang="en-US">
+                    <a:noFill/>
+                  </a:rPr>
+                  <a:t> </a:t>
+                </a:r>
+              </a:p>
+            </p:txBody>
+          </p:sp>
+        </mc:Fallback>
+      </mc:AlternateContent>
+      <mc:AlternateContent xmlns:mc="http://schemas.openxmlformats.org/markup-compatibility/2006">
+        <mc:Choice xmlns:a14="http://schemas.microsoft.com/office/drawing/2010/main" Requires="a14">
+          <p:sp>
+            <p:nvSpPr>
+              <p:cNvPr id="9" name="TextBox 8">
+                <a:extLst>
+                  <a:ext uri="{FF2B5EF4-FFF2-40B4-BE49-F238E27FC236}">
+                    <a16:creationId xmlns:a16="http://schemas.microsoft.com/office/drawing/2014/main" id="{FC6BBA43-E2D3-4C41-1957-FAE81B8A5263}"/>
+                  </a:ext>
+                </a:extLst>
+              </p:cNvPr>
+              <p:cNvSpPr txBox="1"/>
+              <p:nvPr/>
+            </p:nvSpPr>
+            <p:spPr>
+              <a:xfrm>
+                <a:off x="662985" y="4604558"/>
+                <a:ext cx="7091127" cy="954107"/>
+              </a:xfrm>
+              <a:prstGeom prst="rect">
+                <a:avLst/>
+              </a:prstGeom>
+              <a:noFill/>
+            </p:spPr>
+            <p:txBody>
+              <a:bodyPr wrap="square" rtlCol="0">
+                <a:spAutoFit/>
+              </a:bodyPr>
+              <a:lstStyle/>
+              <a:p>
+                <a:r>
+                  <a:rPr lang="en-US" sz="2800" dirty="0"/>
+                  <a:t>At the poles, </a:t>
+                </a:r>
+                <a14:m>
+                  <m:oMath xmlns:m="http://schemas.openxmlformats.org/officeDocument/2006/math">
+                    <m:r>
+                      <a:rPr lang="en-US" sz="2800" i="1" smtClean="0">
+                        <a:latin typeface="Cambria Math" panose="02040503050406030204" pitchFamily="18" charset="0"/>
+                        <a:ea typeface="Cambria Math" panose="02040503050406030204" pitchFamily="18" charset="0"/>
+                      </a:rPr>
+                      <m:t>𝜙</m:t>
+                    </m:r>
+                  </m:oMath>
+                </a14:m>
+                <a:r>
+                  <a:rPr lang="en-US" sz="2800" dirty="0"/>
+                  <a:t> and </a:t>
+                </a:r>
+                <a14:m>
+                  <m:oMath xmlns:m="http://schemas.openxmlformats.org/officeDocument/2006/math">
+                    <m:r>
+                      <a:rPr lang="en-US" sz="2800" i="1" smtClean="0">
+                        <a:latin typeface="Cambria Math" panose="02040503050406030204" pitchFamily="18" charset="0"/>
+                        <a:ea typeface="Cambria Math" panose="02040503050406030204" pitchFamily="18" charset="0"/>
+                      </a:rPr>
+                      <m:t>𝜓</m:t>
+                    </m:r>
+                  </m:oMath>
+                </a14:m>
+                <a:r>
+                  <a:rPr lang="en-US" sz="2800" dirty="0"/>
+                  <a:t> are interchangeable.</a:t>
+                </a:r>
+                <a:br>
+                  <a:rPr lang="en-US" sz="2800" dirty="0"/>
+                </a:br>
+                <a:r>
+                  <a:rPr lang="en-US" sz="2800" dirty="0"/>
+                  <a:t>Any combination of </a:t>
+                </a:r>
+                <a14:m>
+                  <m:oMath xmlns:m="http://schemas.openxmlformats.org/officeDocument/2006/math">
+                    <m:r>
+                      <a:rPr lang="en-US" sz="2800" i="1" smtClean="0">
+                        <a:latin typeface="Cambria Math" panose="02040503050406030204" pitchFamily="18" charset="0"/>
+                        <a:ea typeface="Cambria Math" panose="02040503050406030204" pitchFamily="18" charset="0"/>
+                      </a:rPr>
+                      <m:t>𝜙</m:t>
+                    </m:r>
+                    <m:r>
+                      <a:rPr lang="en-US" sz="2800" b="0" i="1" smtClean="0">
+                        <a:latin typeface="Cambria Math" panose="02040503050406030204" pitchFamily="18" charset="0"/>
+                        <a:ea typeface="Cambria Math" panose="02040503050406030204" pitchFamily="18" charset="0"/>
+                      </a:rPr>
+                      <m:t>+</m:t>
+                    </m:r>
+                    <m:r>
+                      <a:rPr lang="en-US" sz="2800" b="0" i="1" smtClean="0">
+                        <a:latin typeface="Cambria Math" panose="02040503050406030204" pitchFamily="18" charset="0"/>
+                        <a:ea typeface="Cambria Math" panose="02040503050406030204" pitchFamily="18" charset="0"/>
+                      </a:rPr>
+                      <m:t>𝜓</m:t>
+                    </m:r>
+                  </m:oMath>
+                </a14:m>
+                <a:r>
+                  <a:rPr lang="en-US" sz="2800" dirty="0"/>
+                  <a:t> are equally valid.</a:t>
+                </a:r>
+              </a:p>
+            </p:txBody>
+          </p:sp>
+        </mc:Choice>
+        <mc:Fallback>
+          <p:sp>
+            <p:nvSpPr>
+              <p:cNvPr id="9" name="TextBox 8">
+                <a:extLst>
+                  <a:ext uri="{FF2B5EF4-FFF2-40B4-BE49-F238E27FC236}">
+                    <a16:creationId xmlns:a16="http://schemas.microsoft.com/office/drawing/2014/main" id="{FC6BBA43-E2D3-4C41-1957-FAE81B8A5263}"/>
+                  </a:ext>
+                </a:extLst>
+              </p:cNvPr>
+              <p:cNvSpPr txBox="1">
+                <a:spLocks noRot="1" noChangeAspect="1" noMove="1" noResize="1" noEditPoints="1" noAdjustHandles="1" noChangeArrowheads="1" noChangeShapeType="1" noTextEdit="1"/>
+              </p:cNvSpPr>
+              <p:nvPr/>
+            </p:nvSpPr>
+            <p:spPr>
+              <a:xfrm>
+                <a:off x="662985" y="4604558"/>
+                <a:ext cx="7091127" cy="954107"/>
+              </a:xfrm>
+              <a:prstGeom prst="rect">
+                <a:avLst/>
+              </a:prstGeom>
+              <a:blipFill>
+                <a:blip r:embed="rId4"/>
+                <a:stretch>
+                  <a:fillRect l="-1806" t="-6369" b="-16561"/>
+                </a:stretch>
+              </a:blipFill>
+            </p:spPr>
+            <p:txBody>
+              <a:bodyPr/>
+              <a:lstStyle/>
+              <a:p>
+                <a:r>
+                  <a:rPr lang="en-US">
+                    <a:noFill/>
+                  </a:rPr>
+                  <a:t> </a:t>
+                </a:r>
+              </a:p>
+            </p:txBody>
+          </p:sp>
+        </mc:Fallback>
+      </mc:AlternateContent>
+      <p:pic>
+        <p:nvPicPr>
+          <p:cNvPr id="12" name="Picture 11">
+            <a:extLst>
+              <a:ext uri="{FF2B5EF4-FFF2-40B4-BE49-F238E27FC236}">
+                <a16:creationId xmlns:a16="http://schemas.microsoft.com/office/drawing/2014/main" id="{549AD5A2-466F-4F37-1F9F-AC0396DCD0B7}"/>
+              </a:ext>
+            </a:extLst>
+          </p:cNvPr>
+          <p:cNvPicPr>
+            <a:picLocks noChangeAspect="1"/>
+          </p:cNvPicPr>
+          <p:nvPr/>
+        </p:nvPicPr>
+        <p:blipFill>
+          <a:blip r:embed="rId5"/>
+          <a:stretch>
+            <a:fillRect/>
+          </a:stretch>
+        </p:blipFill>
+        <p:spPr>
+          <a:xfrm>
+            <a:off x="8039099" y="2615840"/>
+            <a:ext cx="3789219" cy="3959859"/>
+          </a:xfrm>
+          <a:prstGeom prst="rect">
+            <a:avLst/>
+          </a:prstGeom>
+        </p:spPr>
+      </p:pic>
+      <p:sp>
+        <p:nvSpPr>
+          <p:cNvPr id="13" name="TextBox 12">
+            <a:extLst>
+              <a:ext uri="{FF2B5EF4-FFF2-40B4-BE49-F238E27FC236}">
+                <a16:creationId xmlns:a16="http://schemas.microsoft.com/office/drawing/2014/main" id="{4EA90B91-9704-9F3A-E3FC-05C3400E5443}"/>
+              </a:ext>
+            </a:extLst>
+          </p:cNvPr>
+          <p:cNvSpPr txBox="1"/>
+          <p:nvPr/>
+        </p:nvSpPr>
+        <p:spPr>
+          <a:xfrm>
+            <a:off x="756550" y="264218"/>
+            <a:ext cx="5821864" cy="707886"/>
+          </a:xfrm>
+          <a:prstGeom prst="rect">
+            <a:avLst/>
+          </a:prstGeom>
+          <a:noFill/>
+        </p:spPr>
+        <p:txBody>
+          <a:bodyPr wrap="square" rtlCol="0">
+            <a:spAutoFit/>
+          </a:bodyPr>
+          <a:lstStyle/>
+          <a:p>
+            <a:pPr algn="ctr"/>
+            <a:r>
+              <a:rPr lang="en-US" sz="4000" dirty="0"/>
+              <a:t>Gimbal Lock</a:t>
+            </a:r>
+          </a:p>
+        </p:txBody>
+      </p:sp>
+      <mc:AlternateContent xmlns:mc="http://schemas.openxmlformats.org/markup-compatibility/2006">
+        <mc:Choice xmlns:a14="http://schemas.microsoft.com/office/drawing/2010/main" Requires="a14">
+          <p:sp>
+            <p:nvSpPr>
+              <p:cNvPr id="2" name="Content Placeholder 2">
+                <a:extLst>
+                  <a:ext uri="{FF2B5EF4-FFF2-40B4-BE49-F238E27FC236}">
+                    <a16:creationId xmlns:a16="http://schemas.microsoft.com/office/drawing/2014/main" id="{099C660B-877D-C133-0D0C-F6DB828B4FAD}"/>
+                  </a:ext>
+                </a:extLst>
+              </p:cNvPr>
+              <p:cNvSpPr txBox="1">
+                <a:spLocks/>
+              </p:cNvSpPr>
+              <p:nvPr/>
+            </p:nvSpPr>
+            <p:spPr>
+              <a:xfrm>
+                <a:off x="441036" y="1262207"/>
+                <a:ext cx="6001882" cy="4351338"/>
+              </a:xfrm>
+              <a:prstGeom prst="rect">
+                <a:avLst/>
+              </a:prstGeom>
+            </p:spPr>
+            <p:txBody>
+              <a:bodyPr vert="horz" lIns="91440" tIns="45720" rIns="91440" bIns="45720" rtlCol="0">
+                <a:normAutofit/>
+              </a:bodyPr>
+              <a:lstStyle>
+                <a:lvl1pPr marL="228600" indent="-228600" algn="l" defTabSz="914400" rtl="0" eaLnBrk="1" latinLnBrk="0" hangingPunct="1">
+                  <a:lnSpc>
+                    <a:spcPct val="90000"/>
+                  </a:lnSpc>
+                  <a:spcBef>
+                    <a:spcPts val="1000"/>
+                  </a:spcBef>
+                  <a:buFont typeface="Arial" panose="020B0604020202020204" pitchFamily="34" charset="0"/>
+                  <a:buChar char="•"/>
+                  <a:defRPr sz="2800" kern="1200">
+                    <a:solidFill>
+                      <a:schemeClr val="tx1"/>
+                    </a:solidFill>
+                    <a:latin typeface="+mn-lt"/>
+                    <a:ea typeface="+mn-ea"/>
+                    <a:cs typeface="+mn-cs"/>
+                  </a:defRPr>
+                </a:lvl1pPr>
+                <a:lvl2pPr marL="685800" indent="-228600" algn="l" defTabSz="914400" rtl="0" eaLnBrk="1" latinLnBrk="0" hangingPunct="1">
+                  <a:lnSpc>
+                    <a:spcPct val="90000"/>
+                  </a:lnSpc>
+                  <a:spcBef>
+                    <a:spcPts val="500"/>
+                  </a:spcBef>
+                  <a:buFont typeface="Arial" panose="020B0604020202020204" pitchFamily="34" charset="0"/>
+                  <a:buChar char="•"/>
+                  <a:defRPr sz="2400" kern="1200">
+                    <a:solidFill>
+                      <a:schemeClr val="tx1"/>
+                    </a:solidFill>
+                    <a:latin typeface="+mn-lt"/>
+                    <a:ea typeface="+mn-ea"/>
+                    <a:cs typeface="+mn-cs"/>
+                  </a:defRPr>
+                </a:lvl2pPr>
+                <a:lvl3pPr marL="1143000" indent="-228600" algn="l" defTabSz="914400" rtl="0" eaLnBrk="1" latinLnBrk="0" hangingPunct="1">
+                  <a:lnSpc>
+                    <a:spcPct val="90000"/>
+                  </a:lnSpc>
+                  <a:spcBef>
+                    <a:spcPts val="500"/>
+                  </a:spcBef>
+                  <a:buFont typeface="Arial" panose="020B0604020202020204" pitchFamily="34" charset="0"/>
+                  <a:buChar char="•"/>
+                  <a:defRPr sz="2000" kern="1200">
+                    <a:solidFill>
+                      <a:schemeClr val="tx1"/>
+                    </a:solidFill>
+                    <a:latin typeface="+mn-lt"/>
+                    <a:ea typeface="+mn-ea"/>
+                    <a:cs typeface="+mn-cs"/>
+                  </a:defRPr>
+                </a:lvl3pPr>
+                <a:lvl4pPr marL="1600200" indent="-228600" algn="l" defTabSz="914400" rtl="0" eaLnBrk="1" latinLnBrk="0" hangingPunct="1">
+                  <a:lnSpc>
+                    <a:spcPct val="90000"/>
+                  </a:lnSpc>
+                  <a:spcBef>
+                    <a:spcPts val="500"/>
+                  </a:spcBef>
+                  <a:buFont typeface="Arial" panose="020B0604020202020204" pitchFamily="34" charset="0"/>
+                  <a:buChar char="•"/>
+                  <a:defRPr sz="1800" kern="1200">
+                    <a:solidFill>
+                      <a:schemeClr val="tx1"/>
+                    </a:solidFill>
+                    <a:latin typeface="+mn-lt"/>
+                    <a:ea typeface="+mn-ea"/>
+                    <a:cs typeface="+mn-cs"/>
+                  </a:defRPr>
+                </a:lvl4pPr>
+                <a:lvl5pPr marL="2057400" indent="-228600" algn="l" defTabSz="914400" rtl="0" eaLnBrk="1" latinLnBrk="0" hangingPunct="1">
+                  <a:lnSpc>
+                    <a:spcPct val="90000"/>
+                  </a:lnSpc>
+                  <a:spcBef>
+                    <a:spcPts val="500"/>
+                  </a:spcBef>
+                  <a:buFont typeface="Arial" panose="020B0604020202020204" pitchFamily="34" charset="0"/>
+                  <a:buChar char="•"/>
+                  <a:defRPr sz="1800" kern="1200">
+                    <a:solidFill>
+                      <a:schemeClr val="tx1"/>
+                    </a:solidFill>
+                    <a:latin typeface="+mn-lt"/>
+                    <a:ea typeface="+mn-ea"/>
+                    <a:cs typeface="+mn-cs"/>
+                  </a:defRPr>
+                </a:lvl5pPr>
+                <a:lvl6pPr marL="2514600" indent="-228600" algn="l" defTabSz="914400" rtl="0" eaLnBrk="1" latinLnBrk="0" hangingPunct="1">
+                  <a:lnSpc>
+                    <a:spcPct val="90000"/>
+                  </a:lnSpc>
+                  <a:spcBef>
+                    <a:spcPts val="500"/>
+                  </a:spcBef>
+                  <a:buFont typeface="Arial" panose="020B0604020202020204" pitchFamily="34" charset="0"/>
+                  <a:buChar char="•"/>
+                  <a:defRPr sz="1800" kern="1200">
+                    <a:solidFill>
+                      <a:schemeClr val="tx1"/>
+                    </a:solidFill>
+                    <a:latin typeface="+mn-lt"/>
+                    <a:ea typeface="+mn-ea"/>
+                    <a:cs typeface="+mn-cs"/>
+                  </a:defRPr>
+                </a:lvl6pPr>
+                <a:lvl7pPr marL="2971800" indent="-228600" algn="l" defTabSz="914400" rtl="0" eaLnBrk="1" latinLnBrk="0" hangingPunct="1">
+                  <a:lnSpc>
+                    <a:spcPct val="90000"/>
+                  </a:lnSpc>
+                  <a:spcBef>
+                    <a:spcPts val="500"/>
+                  </a:spcBef>
+                  <a:buFont typeface="Arial" panose="020B0604020202020204" pitchFamily="34" charset="0"/>
+                  <a:buChar char="•"/>
+                  <a:defRPr sz="1800" kern="1200">
+                    <a:solidFill>
+                      <a:schemeClr val="tx1"/>
+                    </a:solidFill>
+                    <a:latin typeface="+mn-lt"/>
+                    <a:ea typeface="+mn-ea"/>
+                    <a:cs typeface="+mn-cs"/>
+                  </a:defRPr>
+                </a:lvl7pPr>
+                <a:lvl8pPr marL="3429000" indent="-228600" algn="l" defTabSz="914400" rtl="0" eaLnBrk="1" latinLnBrk="0" hangingPunct="1">
+                  <a:lnSpc>
+                    <a:spcPct val="90000"/>
+                  </a:lnSpc>
+                  <a:spcBef>
+                    <a:spcPts val="500"/>
+                  </a:spcBef>
+                  <a:buFont typeface="Arial" panose="020B0604020202020204" pitchFamily="34" charset="0"/>
+                  <a:buChar char="•"/>
+                  <a:defRPr sz="1800" kern="1200">
+                    <a:solidFill>
+                      <a:schemeClr val="tx1"/>
+                    </a:solidFill>
+                    <a:latin typeface="+mn-lt"/>
+                    <a:ea typeface="+mn-ea"/>
+                    <a:cs typeface="+mn-cs"/>
+                  </a:defRPr>
+                </a:lvl8pPr>
+                <a:lvl9pPr marL="3886200" indent="-228600" algn="l" defTabSz="914400" rtl="0" eaLnBrk="1" latinLnBrk="0" hangingPunct="1">
+                  <a:lnSpc>
+                    <a:spcPct val="90000"/>
+                  </a:lnSpc>
+                  <a:spcBef>
+                    <a:spcPts val="500"/>
+                  </a:spcBef>
+                  <a:buFont typeface="Arial" panose="020B0604020202020204" pitchFamily="34" charset="0"/>
+                  <a:buChar char="•"/>
+                  <a:defRPr sz="1800" kern="1200">
+                    <a:solidFill>
+                      <a:schemeClr val="tx1"/>
+                    </a:solidFill>
+                    <a:latin typeface="+mn-lt"/>
+                    <a:ea typeface="+mn-ea"/>
+                    <a:cs typeface="+mn-cs"/>
+                  </a:defRPr>
+                </a:lvl9pPr>
+              </a:lstStyle>
+              <a:p>
+                <a:pPr marL="0" indent="0">
+                  <a:buFont typeface="Arial" panose="020B0604020202020204" pitchFamily="34" charset="0"/>
+                  <a:buNone/>
+                </a:pPr>
+                <a14:m>
+                  <m:oMathPara xmlns:m="http://schemas.openxmlformats.org/officeDocument/2006/math">
+                    <m:oMathParaPr>
+                      <m:jc m:val="centerGroup"/>
+                    </m:oMathParaPr>
+                    <m:oMath xmlns:m="http://schemas.openxmlformats.org/officeDocument/2006/math">
+                      <m:acc>
+                        <m:accPr>
+                          <m:chr m:val="̇"/>
+                          <m:ctrlPr>
+                            <a:rPr lang="en-US" i="1" smtClean="0">
+                              <a:latin typeface="Cambria Math" panose="02040503050406030204" pitchFamily="18" charset="0"/>
+                            </a:rPr>
+                          </m:ctrlPr>
+                        </m:accPr>
+                        <m:e>
+                          <m:r>
+                            <a:rPr lang="en-US" i="1" smtClean="0">
+                              <a:latin typeface="Cambria Math" panose="02040503050406030204" pitchFamily="18" charset="0"/>
+                              <a:ea typeface="Cambria Math" panose="02040503050406030204" pitchFamily="18" charset="0"/>
+                            </a:rPr>
+                            <m:t>𝜃</m:t>
+                          </m:r>
+                        </m:e>
+                      </m:acc>
+                      <m:r>
+                        <a:rPr lang="en-US" i="1" smtClean="0">
+                          <a:latin typeface="Cambria Math" panose="02040503050406030204" pitchFamily="18" charset="0"/>
+                        </a:rPr>
+                        <m:t>=</m:t>
+                      </m:r>
+                      <m:r>
+                        <a:rPr lang="en-US" i="1" smtClean="0">
+                          <a:latin typeface="Cambria Math" panose="02040503050406030204" pitchFamily="18" charset="0"/>
+                        </a:rPr>
+                        <m:t>𝑞</m:t>
+                      </m:r>
+                      <m:func>
+                        <m:funcPr>
+                          <m:ctrlPr>
+                            <a:rPr lang="en-US" i="1" smtClean="0">
+                              <a:latin typeface="Cambria Math" panose="02040503050406030204" pitchFamily="18" charset="0"/>
+                            </a:rPr>
+                          </m:ctrlPr>
+                        </m:funcPr>
+                        <m:fName>
+                          <m:r>
+                            <m:rPr>
+                              <m:sty m:val="p"/>
+                            </m:rPr>
+                            <a:rPr lang="en-US" smtClean="0">
+                              <a:latin typeface="Cambria Math" panose="02040503050406030204" pitchFamily="18" charset="0"/>
+                            </a:rPr>
+                            <m:t>cos</m:t>
+                          </m:r>
+                        </m:fName>
+                        <m:e>
+                          <m:r>
+                            <a:rPr lang="en-US" i="1" smtClean="0">
+                              <a:latin typeface="Cambria Math" panose="02040503050406030204" pitchFamily="18" charset="0"/>
+                              <a:ea typeface="Cambria Math" panose="02040503050406030204" pitchFamily="18" charset="0"/>
+                            </a:rPr>
+                            <m:t>𝜙</m:t>
+                          </m:r>
+                        </m:e>
+                      </m:func>
+                      <m:r>
+                        <a:rPr lang="en-US" i="1" smtClean="0">
+                          <a:latin typeface="Cambria Math" panose="02040503050406030204" pitchFamily="18" charset="0"/>
+                        </a:rPr>
+                        <m:t>−</m:t>
+                      </m:r>
+                      <m:r>
+                        <a:rPr lang="en-US" i="1" smtClean="0">
+                          <a:latin typeface="Cambria Math" panose="02040503050406030204" pitchFamily="18" charset="0"/>
+                        </a:rPr>
+                        <m:t>𝑟</m:t>
+                      </m:r>
+                      <m:func>
+                        <m:funcPr>
+                          <m:ctrlPr>
+                            <a:rPr lang="en-US" i="1" smtClean="0">
+                              <a:latin typeface="Cambria Math" panose="02040503050406030204" pitchFamily="18" charset="0"/>
+                            </a:rPr>
+                          </m:ctrlPr>
+                        </m:funcPr>
+                        <m:fName>
+                          <m:r>
+                            <m:rPr>
+                              <m:sty m:val="p"/>
+                            </m:rPr>
+                            <a:rPr lang="en-US" smtClean="0">
+                              <a:latin typeface="Cambria Math" panose="02040503050406030204" pitchFamily="18" charset="0"/>
+                            </a:rPr>
+                            <m:t>sin</m:t>
+                          </m:r>
+                        </m:fName>
+                        <m:e>
+                          <m:r>
+                            <a:rPr lang="en-US" i="1" smtClean="0">
+                              <a:latin typeface="Cambria Math" panose="02040503050406030204" pitchFamily="18" charset="0"/>
+                              <a:ea typeface="Cambria Math" panose="02040503050406030204" pitchFamily="18" charset="0"/>
+                            </a:rPr>
+                            <m:t>𝜙</m:t>
+                          </m:r>
+                        </m:e>
+                      </m:func>
+                    </m:oMath>
+                  </m:oMathPara>
+                </a14:m>
+                <a:endParaRPr lang="en-US" dirty="0"/>
+              </a:p>
+              <a:p>
+                <a:pPr marL="0" indent="0">
+                  <a:buFont typeface="Arial" panose="020B0604020202020204" pitchFamily="34" charset="0"/>
+                  <a:buNone/>
+                </a:pPr>
+                <a:endParaRPr lang="en-US" sz="1200" dirty="0"/>
+              </a:p>
+              <a:p>
+                <a:pPr marL="0" indent="0">
+                  <a:buFont typeface="Arial" panose="020B0604020202020204" pitchFamily="34" charset="0"/>
+                  <a:buNone/>
+                </a:pPr>
+                <a14:m>
+                  <m:oMathPara xmlns:m="http://schemas.openxmlformats.org/officeDocument/2006/math">
+                    <m:oMathParaPr>
+                      <m:jc m:val="centerGroup"/>
+                    </m:oMathParaPr>
+                    <m:oMath xmlns:m="http://schemas.openxmlformats.org/officeDocument/2006/math">
+                      <m:acc>
+                        <m:accPr>
+                          <m:chr m:val="̇"/>
+                          <m:ctrlPr>
+                            <a:rPr lang="en-US" i="1" smtClean="0">
+                              <a:latin typeface="Cambria Math" panose="02040503050406030204" pitchFamily="18" charset="0"/>
+                            </a:rPr>
+                          </m:ctrlPr>
+                        </m:accPr>
+                        <m:e>
+                          <m:r>
+                            <a:rPr lang="en-US" i="1" smtClean="0">
+                              <a:latin typeface="Cambria Math" panose="02040503050406030204" pitchFamily="18" charset="0"/>
+                              <a:ea typeface="Cambria Math" panose="02040503050406030204" pitchFamily="18" charset="0"/>
+                            </a:rPr>
+                            <m:t>𝜓</m:t>
+                          </m:r>
+                        </m:e>
+                      </m:acc>
+                      <m:r>
+                        <a:rPr lang="en-US" i="1" smtClean="0">
+                          <a:latin typeface="Cambria Math" panose="02040503050406030204" pitchFamily="18" charset="0"/>
+                        </a:rPr>
+                        <m:t>=</m:t>
+                      </m:r>
+                      <m:r>
+                        <a:rPr lang="en-US" i="1" smtClean="0">
+                          <a:latin typeface="Cambria Math" panose="02040503050406030204" pitchFamily="18" charset="0"/>
+                        </a:rPr>
+                        <m:t>𝑞</m:t>
+                      </m:r>
+                      <m:f>
+                        <m:fPr>
+                          <m:ctrlPr>
+                            <a:rPr lang="en-US" i="1" smtClean="0">
+                              <a:latin typeface="Cambria Math" panose="02040503050406030204" pitchFamily="18" charset="0"/>
+                            </a:rPr>
+                          </m:ctrlPr>
+                        </m:fPr>
+                        <m:num>
+                          <m:func>
+                            <m:funcPr>
+                              <m:ctrlPr>
+                                <a:rPr lang="en-US" i="1" smtClean="0">
+                                  <a:latin typeface="Cambria Math" panose="02040503050406030204" pitchFamily="18" charset="0"/>
+                                </a:rPr>
+                              </m:ctrlPr>
+                            </m:funcPr>
+                            <m:fName>
+                              <m:r>
+                                <m:rPr>
+                                  <m:sty m:val="p"/>
+                                </m:rPr>
+                                <a:rPr lang="en-US" smtClean="0">
+                                  <a:latin typeface="Cambria Math" panose="02040503050406030204" pitchFamily="18" charset="0"/>
+                                </a:rPr>
+                                <m:t>sin</m:t>
+                              </m:r>
+                            </m:fName>
+                            <m:e>
+                              <m:r>
+                                <a:rPr lang="en-US" i="1" smtClean="0">
+                                  <a:latin typeface="Cambria Math" panose="02040503050406030204" pitchFamily="18" charset="0"/>
+                                  <a:ea typeface="Cambria Math" panose="02040503050406030204" pitchFamily="18" charset="0"/>
+                                </a:rPr>
+                                <m:t>𝜙</m:t>
+                              </m:r>
+                            </m:e>
+                          </m:func>
+                        </m:num>
+                        <m:den>
+                          <m:func>
+                            <m:funcPr>
+                              <m:ctrlPr>
+                                <a:rPr lang="en-US" i="1" smtClean="0">
+                                  <a:latin typeface="Cambria Math" panose="02040503050406030204" pitchFamily="18" charset="0"/>
+                                </a:rPr>
+                              </m:ctrlPr>
+                            </m:funcPr>
+                            <m:fName>
+                              <m:r>
+                                <m:rPr>
+                                  <m:sty m:val="p"/>
+                                </m:rPr>
+                                <a:rPr lang="en-US" smtClean="0">
+                                  <a:latin typeface="Cambria Math" panose="02040503050406030204" pitchFamily="18" charset="0"/>
+                                </a:rPr>
+                                <m:t>cos</m:t>
+                              </m:r>
+                            </m:fName>
+                            <m:e>
+                              <m:r>
+                                <a:rPr lang="en-US" i="1" smtClean="0">
+                                  <a:latin typeface="Cambria Math" panose="02040503050406030204" pitchFamily="18" charset="0"/>
+                                  <a:ea typeface="Cambria Math" panose="02040503050406030204" pitchFamily="18" charset="0"/>
+                                </a:rPr>
+                                <m:t>𝜃</m:t>
+                              </m:r>
+                            </m:e>
+                          </m:func>
+                        </m:den>
+                      </m:f>
+                      <m:r>
+                        <a:rPr lang="en-US" i="1" smtClean="0">
+                          <a:latin typeface="Cambria Math" panose="02040503050406030204" pitchFamily="18" charset="0"/>
+                        </a:rPr>
+                        <m:t>+</m:t>
+                      </m:r>
+                      <m:r>
+                        <a:rPr lang="en-US" i="1" smtClean="0">
+                          <a:latin typeface="Cambria Math" panose="02040503050406030204" pitchFamily="18" charset="0"/>
+                        </a:rPr>
+                        <m:t>𝑟</m:t>
+                      </m:r>
+                      <m:f>
+                        <m:fPr>
+                          <m:ctrlPr>
+                            <a:rPr lang="en-US" i="1" smtClean="0">
+                              <a:latin typeface="Cambria Math" panose="02040503050406030204" pitchFamily="18" charset="0"/>
+                            </a:rPr>
+                          </m:ctrlPr>
+                        </m:fPr>
+                        <m:num>
+                          <m:func>
+                            <m:funcPr>
+                              <m:ctrlPr>
+                                <a:rPr lang="en-US" i="1" smtClean="0">
+                                  <a:latin typeface="Cambria Math" panose="02040503050406030204" pitchFamily="18" charset="0"/>
+                                </a:rPr>
+                              </m:ctrlPr>
+                            </m:funcPr>
+                            <m:fName>
+                              <m:r>
+                                <m:rPr>
+                                  <m:sty m:val="p"/>
+                                </m:rPr>
+                                <a:rPr lang="en-US" smtClean="0">
+                                  <a:latin typeface="Cambria Math" panose="02040503050406030204" pitchFamily="18" charset="0"/>
+                                </a:rPr>
+                                <m:t>cos</m:t>
+                              </m:r>
+                            </m:fName>
+                            <m:e>
+                              <m:r>
+                                <a:rPr lang="en-US" i="1" smtClean="0">
+                                  <a:latin typeface="Cambria Math" panose="02040503050406030204" pitchFamily="18" charset="0"/>
+                                  <a:ea typeface="Cambria Math" panose="02040503050406030204" pitchFamily="18" charset="0"/>
+                                </a:rPr>
+                                <m:t>𝜙</m:t>
+                              </m:r>
+                            </m:e>
+                          </m:func>
+                        </m:num>
+                        <m:den>
+                          <m:func>
+                            <m:funcPr>
+                              <m:ctrlPr>
+                                <a:rPr lang="en-US" i="1" smtClean="0">
+                                  <a:latin typeface="Cambria Math" panose="02040503050406030204" pitchFamily="18" charset="0"/>
+                                </a:rPr>
+                              </m:ctrlPr>
+                            </m:funcPr>
+                            <m:fName>
+                              <m:r>
+                                <m:rPr>
+                                  <m:sty m:val="p"/>
+                                </m:rPr>
+                                <a:rPr lang="en-US" smtClean="0">
+                                  <a:latin typeface="Cambria Math" panose="02040503050406030204" pitchFamily="18" charset="0"/>
+                                </a:rPr>
+                                <m:t>cos</m:t>
+                              </m:r>
+                            </m:fName>
+                            <m:e>
+                              <m:r>
+                                <a:rPr lang="en-US" i="1" smtClean="0">
+                                  <a:latin typeface="Cambria Math" panose="02040503050406030204" pitchFamily="18" charset="0"/>
+                                  <a:ea typeface="Cambria Math" panose="02040503050406030204" pitchFamily="18" charset="0"/>
+                                </a:rPr>
+                                <m:t>𝜃</m:t>
+                              </m:r>
+                            </m:e>
+                          </m:func>
+                        </m:den>
+                      </m:f>
+                    </m:oMath>
+                  </m:oMathPara>
+                </a14:m>
+                <a:endParaRPr lang="en-US" dirty="0"/>
+              </a:p>
+              <a:p>
+                <a:pPr marL="0" indent="0">
+                  <a:buFont typeface="Arial" panose="020B0604020202020204" pitchFamily="34" charset="0"/>
+                  <a:buNone/>
+                </a:pPr>
+                <a:endParaRPr lang="en-US" sz="1200" dirty="0"/>
+              </a:p>
+              <a:p>
+                <a:pPr marL="0" indent="0">
+                  <a:buFont typeface="Arial" panose="020B0604020202020204" pitchFamily="34" charset="0"/>
+                  <a:buNone/>
+                </a:pPr>
+                <a14:m>
+                  <m:oMathPara xmlns:m="http://schemas.openxmlformats.org/officeDocument/2006/math">
+                    <m:oMathParaPr>
+                      <m:jc m:val="centerGroup"/>
+                    </m:oMathParaPr>
+                    <m:oMath xmlns:m="http://schemas.openxmlformats.org/officeDocument/2006/math">
+                      <m:acc>
+                        <m:accPr>
+                          <m:chr m:val="̇"/>
+                          <m:ctrlPr>
+                            <a:rPr lang="en-US" i="1" smtClean="0">
+                              <a:latin typeface="Cambria Math" panose="02040503050406030204" pitchFamily="18" charset="0"/>
+                            </a:rPr>
+                          </m:ctrlPr>
+                        </m:accPr>
+                        <m:e>
+                          <m:r>
+                            <a:rPr lang="en-US" i="1" smtClean="0">
+                              <a:latin typeface="Cambria Math" panose="02040503050406030204" pitchFamily="18" charset="0"/>
+                              <a:ea typeface="Cambria Math" panose="02040503050406030204" pitchFamily="18" charset="0"/>
+                            </a:rPr>
+                            <m:t>𝜙</m:t>
+                          </m:r>
+                        </m:e>
+                      </m:acc>
+                      <m:r>
+                        <a:rPr lang="en-US" i="1" smtClean="0">
+                          <a:latin typeface="Cambria Math" panose="02040503050406030204" pitchFamily="18" charset="0"/>
+                        </a:rPr>
+                        <m:t>=</m:t>
+                      </m:r>
+                      <m:r>
+                        <a:rPr lang="en-US" i="1" smtClean="0">
+                          <a:latin typeface="Cambria Math" panose="02040503050406030204" pitchFamily="18" charset="0"/>
+                        </a:rPr>
+                        <m:t>𝑝</m:t>
+                      </m:r>
+                      <m:r>
+                        <a:rPr lang="en-US" i="1" smtClean="0">
+                          <a:latin typeface="Cambria Math" panose="02040503050406030204" pitchFamily="18" charset="0"/>
+                        </a:rPr>
+                        <m:t>+</m:t>
+                      </m:r>
+                      <m:r>
+                        <a:rPr lang="en-US" i="1" smtClean="0">
+                          <a:latin typeface="Cambria Math" panose="02040503050406030204" pitchFamily="18" charset="0"/>
+                        </a:rPr>
+                        <m:t>𝑞</m:t>
+                      </m:r>
+                      <m:func>
+                        <m:funcPr>
+                          <m:ctrlPr>
+                            <a:rPr lang="en-US" i="1" smtClean="0">
+                              <a:latin typeface="Cambria Math" panose="02040503050406030204" pitchFamily="18" charset="0"/>
+                            </a:rPr>
+                          </m:ctrlPr>
+                        </m:funcPr>
+                        <m:fName>
+                          <m:r>
+                            <m:rPr>
+                              <m:sty m:val="p"/>
+                            </m:rPr>
+                            <a:rPr lang="en-US" smtClean="0">
+                              <a:latin typeface="Cambria Math" panose="02040503050406030204" pitchFamily="18" charset="0"/>
+                            </a:rPr>
+                            <m:t>sin</m:t>
+                          </m:r>
+                        </m:fName>
+                        <m:e>
+                          <m:r>
+                            <a:rPr lang="en-US" i="1" smtClean="0">
+                              <a:latin typeface="Cambria Math" panose="02040503050406030204" pitchFamily="18" charset="0"/>
+                              <a:ea typeface="Cambria Math" panose="02040503050406030204" pitchFamily="18" charset="0"/>
+                            </a:rPr>
+                            <m:t>𝜙</m:t>
+                          </m:r>
+                        </m:e>
+                      </m:func>
+                      <m:func>
+                        <m:funcPr>
+                          <m:ctrlPr>
+                            <a:rPr lang="en-US" i="1" smtClean="0">
+                              <a:latin typeface="Cambria Math" panose="02040503050406030204" pitchFamily="18" charset="0"/>
+                            </a:rPr>
+                          </m:ctrlPr>
+                        </m:funcPr>
+                        <m:fName>
+                          <m:r>
+                            <m:rPr>
+                              <m:sty m:val="p"/>
+                            </m:rPr>
+                            <a:rPr lang="en-US" smtClean="0">
+                              <a:latin typeface="Cambria Math" panose="02040503050406030204" pitchFamily="18" charset="0"/>
+                            </a:rPr>
+                            <m:t>tan</m:t>
+                          </m:r>
+                        </m:fName>
+                        <m:e>
+                          <m:r>
+                            <a:rPr lang="en-US" i="1" smtClean="0">
+                              <a:latin typeface="Cambria Math" panose="02040503050406030204" pitchFamily="18" charset="0"/>
+                              <a:ea typeface="Cambria Math" panose="02040503050406030204" pitchFamily="18" charset="0"/>
+                            </a:rPr>
+                            <m:t>𝜃</m:t>
+                          </m:r>
+                        </m:e>
+                      </m:func>
+                      <m:r>
+                        <a:rPr lang="en-US" i="1" smtClean="0">
+                          <a:latin typeface="Cambria Math" panose="02040503050406030204" pitchFamily="18" charset="0"/>
+                        </a:rPr>
+                        <m:t>+</m:t>
+                      </m:r>
+                      <m:r>
+                        <a:rPr lang="en-US" i="1" smtClean="0">
+                          <a:latin typeface="Cambria Math" panose="02040503050406030204" pitchFamily="18" charset="0"/>
+                        </a:rPr>
+                        <m:t>𝑟</m:t>
+                      </m:r>
+                      <m:func>
+                        <m:funcPr>
+                          <m:ctrlPr>
+                            <a:rPr lang="en-US" i="1" smtClean="0">
+                              <a:latin typeface="Cambria Math" panose="02040503050406030204" pitchFamily="18" charset="0"/>
+                            </a:rPr>
+                          </m:ctrlPr>
+                        </m:funcPr>
+                        <m:fName>
+                          <m:r>
+                            <m:rPr>
+                              <m:sty m:val="p"/>
+                            </m:rPr>
+                            <a:rPr lang="en-US" smtClean="0">
+                              <a:latin typeface="Cambria Math" panose="02040503050406030204" pitchFamily="18" charset="0"/>
+                            </a:rPr>
+                            <m:t>cos</m:t>
+                          </m:r>
+                        </m:fName>
+                        <m:e>
+                          <m:r>
+                            <a:rPr lang="en-US" i="1" smtClean="0">
+                              <a:latin typeface="Cambria Math" panose="02040503050406030204" pitchFamily="18" charset="0"/>
+                              <a:ea typeface="Cambria Math" panose="02040503050406030204" pitchFamily="18" charset="0"/>
+                            </a:rPr>
+                            <m:t>𝜙</m:t>
+                          </m:r>
+                        </m:e>
+                      </m:func>
+                      <m:func>
+                        <m:funcPr>
+                          <m:ctrlPr>
+                            <a:rPr lang="en-US" i="1" smtClean="0">
+                              <a:latin typeface="Cambria Math" panose="02040503050406030204" pitchFamily="18" charset="0"/>
+                            </a:rPr>
+                          </m:ctrlPr>
+                        </m:funcPr>
+                        <m:fName>
+                          <m:r>
+                            <m:rPr>
+                              <m:sty m:val="p"/>
+                            </m:rPr>
+                            <a:rPr lang="en-US" smtClean="0">
+                              <a:latin typeface="Cambria Math" panose="02040503050406030204" pitchFamily="18" charset="0"/>
+                            </a:rPr>
+                            <m:t>tan</m:t>
+                          </m:r>
+                        </m:fName>
+                        <m:e>
+                          <m:r>
+                            <a:rPr lang="en-US" i="1" smtClean="0">
+                              <a:latin typeface="Cambria Math" panose="02040503050406030204" pitchFamily="18" charset="0"/>
+                              <a:ea typeface="Cambria Math" panose="02040503050406030204" pitchFamily="18" charset="0"/>
+                            </a:rPr>
+                            <m:t>𝜃</m:t>
+                          </m:r>
+                        </m:e>
+                      </m:func>
+                    </m:oMath>
+                  </m:oMathPara>
+                </a14:m>
+                <a:endParaRPr lang="en-US" dirty="0"/>
+              </a:p>
+            </p:txBody>
+          </p:sp>
+        </mc:Choice>
+        <mc:Fallback>
+          <p:sp>
+            <p:nvSpPr>
+              <p:cNvPr id="2" name="Content Placeholder 2">
+                <a:extLst>
+                  <a:ext uri="{FF2B5EF4-FFF2-40B4-BE49-F238E27FC236}">
+                    <a16:creationId xmlns:a16="http://schemas.microsoft.com/office/drawing/2014/main" id="{099C660B-877D-C133-0D0C-F6DB828B4FAD}"/>
+                  </a:ext>
+                </a:extLst>
+              </p:cNvPr>
+              <p:cNvSpPr txBox="1">
+                <a:spLocks noRot="1" noChangeAspect="1" noMove="1" noResize="1" noEditPoints="1" noAdjustHandles="1" noChangeArrowheads="1" noChangeShapeType="1" noTextEdit="1"/>
+              </p:cNvSpPr>
+              <p:nvPr/>
+            </p:nvSpPr>
+            <p:spPr>
+              <a:xfrm>
+                <a:off x="441036" y="1262207"/>
+                <a:ext cx="6001882" cy="4351338"/>
+              </a:xfrm>
+              <a:prstGeom prst="rect">
+                <a:avLst/>
+              </a:prstGeom>
+              <a:blipFill>
+                <a:blip r:embed="rId6"/>
+                <a:stretch>
+                  <a:fillRect t="-1541"/>
+                </a:stretch>
+              </a:blipFill>
+            </p:spPr>
+            <p:txBody>
+              <a:bodyPr/>
+              <a:lstStyle/>
+              <a:p>
+                <a:r>
+                  <a:rPr lang="en-US">
+                    <a:noFill/>
+                  </a:rPr>
+                  <a:t> </a:t>
+                </a:r>
+              </a:p>
+            </p:txBody>
+          </p:sp>
+        </mc:Fallback>
+      </mc:AlternateContent>
+    </p:spTree>
+    <p:extLst>
+      <p:ext uri="{BB962C8B-B14F-4D97-AF65-F5344CB8AC3E}">
+        <p14:creationId xmlns:p14="http://schemas.microsoft.com/office/powerpoint/2010/main" val="861825399"/>
+      </p:ext>
+    </p:extLst>
+  </p:cSld>
+  <p:clrMapOvr>
+    <a:masterClrMapping/>
+  </p:clrMapOvr>
+  <p:timing>
+    <p:tnLst>
+      <p:par>
+        <p:cTn id="1" dur="indefinite" restart="never" nodeType="tmRoot">
+          <p:childTnLst>
+            <p:seq concurrent="1" nextAc="seek">
+              <p:cTn id="2" dur="indefinite" nodeType="mainSeq">
+                <p:childTnLst>
+                  <p:par>
+                    <p:cTn id="3" fill="hold">
+                      <p:stCondLst>
+                        <p:cond delay="indefinite"/>
+                      </p:stCondLst>
+                      <p:childTnLst>
+                        <p:par>
+                          <p:cTn id="4" fill="hold">
+                            <p:stCondLst>
+                              <p:cond delay="0"/>
+                            </p:stCondLst>
+                            <p:childTnLst>
+                              <p:par>
+                                <p:cTn id="5" presetID="42" presetClass="entr" presetSubtype="0" fill="hold" grpId="0" nodeType="clickEffect">
+                                  <p:stCondLst>
+                                    <p:cond delay="0"/>
+                                  </p:stCondLst>
+                                  <p:childTnLst>
+                                    <p:set>
+                                      <p:cBhvr>
+                                        <p:cTn id="6" dur="1" fill="hold">
+                                          <p:stCondLst>
+                                            <p:cond delay="0"/>
+                                          </p:stCondLst>
+                                        </p:cTn>
+                                        <p:tgtEl>
+                                          <p:spTgt spid="9"/>
+                                        </p:tgtEl>
+                                        <p:attrNameLst>
+                                          <p:attrName>style.visibility</p:attrName>
+                                        </p:attrNameLst>
+                                      </p:cBhvr>
+                                      <p:to>
+                                        <p:strVal val="visible"/>
+                                      </p:to>
+                                    </p:set>
+                                    <p:animEffect transition="in" filter="fade">
+                                      <p:cBhvr>
+                                        <p:cTn id="7" dur="1000"/>
+                                        <p:tgtEl>
+                                          <p:spTgt spid="9"/>
+                                        </p:tgtEl>
+                                      </p:cBhvr>
+                                    </p:animEffect>
+                                    <p:anim calcmode="lin" valueType="num">
+                                      <p:cBhvr>
+                                        <p:cTn id="8" dur="1000" fill="hold"/>
+                                        <p:tgtEl>
+                                          <p:spTgt spid="9"/>
+                                        </p:tgtEl>
+                                        <p:attrNameLst>
+                                          <p:attrName>ppt_x</p:attrName>
+                                        </p:attrNameLst>
+                                      </p:cBhvr>
+                                      <p:tavLst>
+                                        <p:tav tm="0">
+                                          <p:val>
+                                            <p:strVal val="#ppt_x"/>
+                                          </p:val>
+                                        </p:tav>
+                                        <p:tav tm="100000">
+                                          <p:val>
+                                            <p:strVal val="#ppt_x"/>
+                                          </p:val>
+                                        </p:tav>
+                                      </p:tavLst>
+                                    </p:anim>
+                                    <p:anim calcmode="lin" valueType="num">
+                                      <p:cBhvr>
+                                        <p:cTn id="9" dur="1000" fill="hold"/>
+                                        <p:tgtEl>
+                                          <p:spTgt spid="9"/>
+                                        </p:tgtEl>
+                                        <p:attrNameLst>
+                                          <p:attrName>ppt_y</p:attrName>
+                                        </p:attrNameLst>
+                                      </p:cBhvr>
+                                      <p:tavLst>
+                                        <p:tav tm="0">
+                                          <p:val>
+                                            <p:strVal val="#ppt_y+.1"/>
+                                          </p:val>
+                                        </p:tav>
+                                        <p:tav tm="100000">
+                                          <p:val>
+                                            <p:strVal val="#ppt_y"/>
+                                          </p:val>
+                                        </p:tav>
+                                      </p:tavLst>
+                                    </p:anim>
+                                  </p:childTnLst>
+                                </p:cTn>
+                              </p:par>
+                            </p:childTnLst>
+                          </p:cTn>
+                        </p:par>
+                      </p:childTnLst>
+                    </p:cTn>
+                  </p:par>
+                  <p:par>
+                    <p:cTn id="10" fill="hold">
+                      <p:stCondLst>
+                        <p:cond delay="indefinite"/>
+                      </p:stCondLst>
+                      <p:childTnLst>
+                        <p:par>
+                          <p:cTn id="11" fill="hold">
+                            <p:stCondLst>
+                              <p:cond delay="0"/>
+                            </p:stCondLst>
+                            <p:childTnLst>
+                              <p:par>
+                                <p:cTn id="12" presetID="10" presetClass="exit" presetSubtype="0" fill="hold" grpId="0" nodeType="clickEffect">
+                                  <p:stCondLst>
+                                    <p:cond delay="0"/>
+                                  </p:stCondLst>
+                                  <p:childTnLst>
+                                    <p:animEffect transition="out" filter="fade">
+                                      <p:cBhvr>
+                                        <p:cTn id="13" dur="500"/>
+                                        <p:tgtEl>
+                                          <p:spTgt spid="2"/>
+                                        </p:tgtEl>
+                                      </p:cBhvr>
+                                    </p:animEffect>
+                                    <p:set>
+                                      <p:cBhvr>
+                                        <p:cTn id="14" dur="1" fill="hold">
+                                          <p:stCondLst>
+                                            <p:cond delay="499"/>
+                                          </p:stCondLst>
+                                        </p:cTn>
+                                        <p:tgtEl>
+                                          <p:spTgt spid="2"/>
+                                        </p:tgtEl>
+                                        <p:attrNameLst>
+                                          <p:attrName>style.visibility</p:attrName>
+                                        </p:attrNameLst>
+                                      </p:cBhvr>
+                                      <p:to>
+                                        <p:strVal val="hidden"/>
+                                      </p:to>
+                                    </p:set>
+                                  </p:childTnLst>
+                                </p:cTn>
+                              </p:par>
+                              <p:par>
+                                <p:cTn id="15" presetID="42" presetClass="entr" presetSubtype="0" fill="hold" grpId="0" nodeType="withEffect">
+                                  <p:stCondLst>
+                                    <p:cond delay="0"/>
+                                  </p:stCondLst>
+                                  <p:childTnLst>
+                                    <p:set>
+                                      <p:cBhvr>
+                                        <p:cTn id="16" dur="1" fill="hold">
+                                          <p:stCondLst>
+                                            <p:cond delay="0"/>
+                                          </p:stCondLst>
+                                        </p:cTn>
+                                        <p:tgtEl>
+                                          <p:spTgt spid="3">
+                                            <p:txEl>
+                                              <p:pRg st="0" end="0"/>
+                                            </p:txEl>
+                                          </p:spTgt>
+                                        </p:tgtEl>
+                                        <p:attrNameLst>
+                                          <p:attrName>style.visibility</p:attrName>
+                                        </p:attrNameLst>
+                                      </p:cBhvr>
+                                      <p:to>
+                                        <p:strVal val="visible"/>
+                                      </p:to>
+                                    </p:set>
+                                    <p:animEffect transition="in" filter="fade">
+                                      <p:cBhvr>
+                                        <p:cTn id="17" dur="1000"/>
+                                        <p:tgtEl>
+                                          <p:spTgt spid="3">
+                                            <p:txEl>
+                                              <p:pRg st="0" end="0"/>
+                                            </p:txEl>
+                                          </p:spTgt>
+                                        </p:tgtEl>
+                                      </p:cBhvr>
+                                    </p:animEffect>
+                                    <p:anim calcmode="lin" valueType="num">
+                                      <p:cBhvr>
+                                        <p:cTn id="18" dur="1000" fill="hold"/>
+                                        <p:tgtEl>
+                                          <p:spTgt spid="3">
+                                            <p:txEl>
+                                              <p:pRg st="0" end="0"/>
+                                            </p:txEl>
+                                          </p:spTgt>
+                                        </p:tgtEl>
+                                        <p:attrNameLst>
+                                          <p:attrName>ppt_x</p:attrName>
+                                        </p:attrNameLst>
+                                      </p:cBhvr>
+                                      <p:tavLst>
+                                        <p:tav tm="0">
+                                          <p:val>
+                                            <p:strVal val="#ppt_x"/>
+                                          </p:val>
+                                        </p:tav>
+                                        <p:tav tm="100000">
+                                          <p:val>
+                                            <p:strVal val="#ppt_x"/>
+                                          </p:val>
+                                        </p:tav>
+                                      </p:tavLst>
+                                    </p:anim>
+                                    <p:anim calcmode="lin" valueType="num">
+                                      <p:cBhvr>
+                                        <p:cTn id="19" dur="1000" fill="hold"/>
+                                        <p:tgtEl>
+                                          <p:spTgt spid="3">
+                                            <p:txEl>
+                                              <p:pRg st="0" end="0"/>
+                                            </p:txEl>
+                                          </p:spTgt>
+                                        </p:tgtEl>
+                                        <p:attrNameLst>
+                                          <p:attrName>ppt_y</p:attrName>
+                                        </p:attrNameLst>
+                                      </p:cBhvr>
+                                      <p:tavLst>
+                                        <p:tav tm="0">
+                                          <p:val>
+                                            <p:strVal val="#ppt_y+.1"/>
+                                          </p:val>
+                                        </p:tav>
+                                        <p:tav tm="100000">
+                                          <p:val>
+                                            <p:strVal val="#ppt_y"/>
+                                          </p:val>
+                                        </p:tav>
+                                      </p:tavLst>
+                                    </p:anim>
+                                  </p:childTnLst>
+                                </p:cTn>
+                              </p:par>
+                            </p:childTnLst>
+                          </p:cTn>
+                        </p:par>
+                        <p:par>
+                          <p:cTn id="20" fill="hold">
+                            <p:stCondLst>
+                              <p:cond delay="1000"/>
+                            </p:stCondLst>
+                            <p:childTnLst>
+                              <p:par>
+                                <p:cTn id="21" presetID="42" presetClass="entr" presetSubtype="0" fill="hold" grpId="0" nodeType="afterEffect">
+                                  <p:stCondLst>
+                                    <p:cond delay="0"/>
+                                  </p:stCondLst>
+                                  <p:childTnLst>
+                                    <p:set>
+                                      <p:cBhvr>
+                                        <p:cTn id="22" dur="1" fill="hold">
+                                          <p:stCondLst>
+                                            <p:cond delay="0"/>
+                                          </p:stCondLst>
+                                        </p:cTn>
+                                        <p:tgtEl>
+                                          <p:spTgt spid="3">
+                                            <p:txEl>
+                                              <p:pRg st="2" end="2"/>
+                                            </p:txEl>
+                                          </p:spTgt>
+                                        </p:tgtEl>
+                                        <p:attrNameLst>
+                                          <p:attrName>style.visibility</p:attrName>
+                                        </p:attrNameLst>
+                                      </p:cBhvr>
+                                      <p:to>
+                                        <p:strVal val="visible"/>
+                                      </p:to>
+                                    </p:set>
+                                    <p:animEffect transition="in" filter="fade">
+                                      <p:cBhvr>
+                                        <p:cTn id="23" dur="1000"/>
+                                        <p:tgtEl>
+                                          <p:spTgt spid="3">
+                                            <p:txEl>
+                                              <p:pRg st="2" end="2"/>
+                                            </p:txEl>
+                                          </p:spTgt>
+                                        </p:tgtEl>
+                                      </p:cBhvr>
+                                    </p:animEffect>
+                                    <p:anim calcmode="lin" valueType="num">
+                                      <p:cBhvr>
+                                        <p:cTn id="24" dur="1000" fill="hold"/>
+                                        <p:tgtEl>
+                                          <p:spTgt spid="3">
+                                            <p:txEl>
+                                              <p:pRg st="2" end="2"/>
+                                            </p:txEl>
+                                          </p:spTgt>
+                                        </p:tgtEl>
+                                        <p:attrNameLst>
+                                          <p:attrName>ppt_x</p:attrName>
+                                        </p:attrNameLst>
+                                      </p:cBhvr>
+                                      <p:tavLst>
+                                        <p:tav tm="0">
+                                          <p:val>
+                                            <p:strVal val="#ppt_x"/>
+                                          </p:val>
+                                        </p:tav>
+                                        <p:tav tm="100000">
+                                          <p:val>
+                                            <p:strVal val="#ppt_x"/>
+                                          </p:val>
+                                        </p:tav>
+                                      </p:tavLst>
+                                    </p:anim>
+                                    <p:anim calcmode="lin" valueType="num">
+                                      <p:cBhvr>
+                                        <p:cTn id="25" dur="1000" fill="hold"/>
+                                        <p:tgtEl>
+                                          <p:spTgt spid="3">
+                                            <p:txEl>
+                                              <p:pRg st="2" end="2"/>
+                                            </p:txEl>
+                                          </p:spTgt>
+                                        </p:tgtEl>
+                                        <p:attrNameLst>
+                                          <p:attrName>ppt_y</p:attrName>
+                                        </p:attrNameLst>
+                                      </p:cBhvr>
+                                      <p:tavLst>
+                                        <p:tav tm="0">
+                                          <p:val>
+                                            <p:strVal val="#ppt_y+.1"/>
+                                          </p:val>
+                                        </p:tav>
+                                        <p:tav tm="100000">
+                                          <p:val>
+                                            <p:strVal val="#ppt_y"/>
+                                          </p:val>
+                                        </p:tav>
+                                      </p:tavLst>
+                                    </p:anim>
+                                  </p:childTnLst>
+                                </p:cTn>
+                              </p:par>
+                            </p:childTnLst>
+                          </p:cTn>
+                        </p:par>
+                        <p:par>
+                          <p:cTn id="26" fill="hold">
+                            <p:stCondLst>
+                              <p:cond delay="2000"/>
+                            </p:stCondLst>
+                            <p:childTnLst>
+                              <p:par>
+                                <p:cTn id="27" presetID="42" presetClass="entr" presetSubtype="0" fill="hold" grpId="0" nodeType="afterEffect">
+                                  <p:stCondLst>
+                                    <p:cond delay="0"/>
+                                  </p:stCondLst>
+                                  <p:childTnLst>
+                                    <p:set>
+                                      <p:cBhvr>
+                                        <p:cTn id="28" dur="1" fill="hold">
+                                          <p:stCondLst>
+                                            <p:cond delay="0"/>
+                                          </p:stCondLst>
+                                        </p:cTn>
+                                        <p:tgtEl>
+                                          <p:spTgt spid="3">
+                                            <p:txEl>
+                                              <p:pRg st="4" end="4"/>
+                                            </p:txEl>
+                                          </p:spTgt>
+                                        </p:tgtEl>
+                                        <p:attrNameLst>
+                                          <p:attrName>style.visibility</p:attrName>
+                                        </p:attrNameLst>
+                                      </p:cBhvr>
+                                      <p:to>
+                                        <p:strVal val="visible"/>
+                                      </p:to>
+                                    </p:set>
+                                    <p:animEffect transition="in" filter="fade">
+                                      <p:cBhvr>
+                                        <p:cTn id="29" dur="1000"/>
+                                        <p:tgtEl>
+                                          <p:spTgt spid="3">
+                                            <p:txEl>
+                                              <p:pRg st="4" end="4"/>
+                                            </p:txEl>
+                                          </p:spTgt>
+                                        </p:tgtEl>
+                                      </p:cBhvr>
+                                    </p:animEffect>
+                                    <p:anim calcmode="lin" valueType="num">
+                                      <p:cBhvr>
+                                        <p:cTn id="30" dur="1000" fill="hold"/>
+                                        <p:tgtEl>
+                                          <p:spTgt spid="3">
+                                            <p:txEl>
+                                              <p:pRg st="4" end="4"/>
+                                            </p:txEl>
+                                          </p:spTgt>
+                                        </p:tgtEl>
+                                        <p:attrNameLst>
+                                          <p:attrName>ppt_x</p:attrName>
+                                        </p:attrNameLst>
+                                      </p:cBhvr>
+                                      <p:tavLst>
+                                        <p:tav tm="0">
+                                          <p:val>
+                                            <p:strVal val="#ppt_x"/>
+                                          </p:val>
+                                        </p:tav>
+                                        <p:tav tm="100000">
+                                          <p:val>
+                                            <p:strVal val="#ppt_x"/>
+                                          </p:val>
+                                        </p:tav>
+                                      </p:tavLst>
+                                    </p:anim>
+                                    <p:anim calcmode="lin" valueType="num">
+                                      <p:cBhvr>
+                                        <p:cTn id="31" dur="1000" fill="hold"/>
+                                        <p:tgtEl>
+                                          <p:spTgt spid="3">
+                                            <p:txEl>
+                                              <p:pRg st="4" end="4"/>
+                                            </p:txEl>
+                                          </p:spTgt>
+                                        </p:tgtEl>
+                                        <p:attrNameLst>
+                                          <p:attrName>ppt_y</p:attrName>
+                                        </p:attrNameLst>
+                                      </p:cBhvr>
+                                      <p:tavLst>
+                                        <p:tav tm="0">
+                                          <p:val>
+                                            <p:strVal val="#ppt_y+.1"/>
+                                          </p:val>
+                                        </p:tav>
+                                        <p:tav tm="100000">
+                                          <p:val>
+                                            <p:strVal val="#ppt_y"/>
+                                          </p:val>
+                                        </p:tav>
+                                      </p:tavLst>
+                                    </p:anim>
+                                  </p:childTnLst>
+                                </p:cTn>
+                              </p:par>
+                            </p:childTnLst>
+                          </p:cTn>
+                        </p:par>
+                      </p:childTnLst>
+                    </p:cTn>
+                  </p:par>
+                </p:childTnLst>
+              </p:cTn>
+              <p:prevCondLst>
+                <p:cond evt="onPrev" delay="0">
+                  <p:tgtEl>
+                    <p:sldTgt/>
+                  </p:tgtEl>
+                </p:cond>
+              </p:prevCondLst>
+              <p:nextCondLst>
+                <p:cond evt="onNext" delay="0">
+                  <p:tgtEl>
+                    <p:sldTgt/>
+                  </p:tgtEl>
+                </p:cond>
+              </p:nextCondLst>
+            </p:seq>
+          </p:childTnLst>
+        </p:cTn>
+      </p:par>
+    </p:tnLst>
+    <p:bldLst>
+      <p:bldP spid="3" grpId="0" uiExpand="1" build="p"/>
+      <p:bldP spid="9" grpId="0"/>
+      <p:bldP spid="2" grpId="0"/>
+    </p:bldLst>
+  </p:timing>
 </p:sld>
 </file>
 

</xml_diff>